<commit_message>
Update project presentation slides and presenter notes to include Objectives, Dataset, Workflow, Challenges, Conclusion, Future Directions, and GitHub details
</commit_message>
<xml_diff>
--- a/Instruction Tuning for Educational QA.pptx
+++ b/Instruction Tuning for Educational QA.pptx
@@ -10,6 +10,9 @@
     <p:sldId id="258" r:id="rId9"/>
     <p:sldId id="259" r:id="rId10"/>
     <p:sldId id="260" r:id="rId11"/>
+    <p:sldId id="261" r:id="rId12"/>
+    <p:sldId id="262" r:id="rId13"/>
+    <p:sldId id="263" r:id="rId14"/>
   </p:sldIdLst>
   <p:sldSz cx="12191695" cy="6858000" type="screen4x3"/>
   <p:notesSz cx="6858000" cy="9144000"/>
@@ -3208,7 +3211,7 @@
               </a:defRPr>
             </a:pPr>
             <a:r>
-              <a:t>A framework for training and deploying domain-specific educational assistants locally on CPU</a:t>
+              <a:t>Deploying domain-specific educational question-answering systems locally with zero cloud dependence.</a:t>
             </a:r>
           </a:p>
         </p:txBody>
@@ -3319,7 +3322,7 @@
               </a:defRPr>
             </a:pPr>
             <a:r>
-              <a:t>PIPELINE &amp; ARCHITECTURE</a:t>
+              <a:t>CORE OBJECTIVES</a:t>
             </a:r>
           </a:p>
         </p:txBody>
@@ -3355,7 +3358,7 @@
               </a:defRPr>
             </a:pPr>
             <a:r>
-              <a:t>End-to-End Development Pipeline</a:t>
+              <a:t>Project Objectives</a:t>
             </a:r>
           </a:p>
         </p:txBody>
@@ -3391,7 +3394,7 @@
               </a:defRPr>
             </a:pPr>
             <a:r>
-              <a:t>The complete cycle from instruction data engineering to local execution.</a:t>
+              <a:t>Key motivations behind training a lightweight model for educational environments.</a:t>
             </a:r>
           </a:p>
         </p:txBody>
@@ -3405,7 +3408,7 @@
         <p:spPr>
           <a:xfrm>
             <a:off x="548640" y="1920240"/>
-            <a:ext cx="2560320" cy="4114800"/>
+            <a:ext cx="3474720" cy="3931920"/>
           </a:xfrm>
           <a:prstGeom prst="roundRect">
             <a:avLst/>
@@ -3450,7 +3453,7 @@
         <p:spPr>
           <a:xfrm>
             <a:off x="548640" y="1920240"/>
-            <a:ext cx="2560320" cy="109728"/>
+            <a:ext cx="3474720" cy="109728"/>
           </a:xfrm>
           <a:prstGeom prst="rect">
             <a:avLst/>
@@ -3494,8 +3497,8 @@
         </p:nvSpPr>
         <p:spPr>
           <a:xfrm>
-            <a:off x="685800" y="2148840"/>
-            <a:ext cx="2286000" cy="3749040"/>
+            <a:off x="731520" y="2194560"/>
+            <a:ext cx="3108960" cy="3474720"/>
           </a:xfrm>
           <a:prstGeom prst="rect">
             <a:avLst/>
@@ -3528,7 +3531,7 @@
               <a:spcAft>
                 <a:spcPts val="800"/>
               </a:spcAft>
-              <a:defRPr sz="1600" b="1">
+              <a:defRPr sz="1800" b="1">
                 <a:solidFill>
                   <a:srgbClr val="0F172A"/>
                 </a:solidFill>
@@ -3536,15 +3539,15 @@
               </a:defRPr>
             </a:pPr>
             <a:r>
-              <a:t>Data Engineering</a:t>
-            </a:r>
-          </a:p>
-          <a:p>
-            <a:pPr algn="l">
+              <a:t>CPU-Only Accessibility</a:t>
+            </a:r>
+          </a:p>
+          <a:p>
+            <a:pPr>
               <a:spcBef>
-                <a:spcPts val="300"/>
+                <a:spcPts val="400"/>
               </a:spcBef>
-              <a:defRPr sz="950">
+              <a:defRPr sz="1050">
                 <a:solidFill>
                   <a:srgbClr val="475569"/>
                 </a:solidFill>
@@ -3552,15 +3555,15 @@
               </a:defRPr>
             </a:pPr>
             <a:r>
-              <a:t>• Dataset: tatsu-lab/alpaca on HuggingFace</a:t>
-            </a:r>
-          </a:p>
-          <a:p>
-            <a:pPr algn="l">
+              <a:t>• Remove reliance on expensive GPU hardware.</a:t>
+            </a:r>
+          </a:p>
+          <a:p>
+            <a:pPr>
               <a:spcBef>
-                <a:spcPts val="300"/>
+                <a:spcPts val="400"/>
               </a:spcBef>
-              <a:defRPr sz="950">
+              <a:defRPr sz="1050">
                 <a:solidFill>
                   <a:srgbClr val="475569"/>
                 </a:solidFill>
@@ -3568,15 +3571,15 @@
               </a:defRPr>
             </a:pPr>
             <a:r>
-              <a:t>• Subset: 1,000 instruction-following samples</a:t>
-            </a:r>
-          </a:p>
-          <a:p>
-            <a:pPr algn="l">
+              <a:t>• Make model training and execution feasible on standard consumer laptops with ~6GB RAM.</a:t>
+            </a:r>
+          </a:p>
+          <a:p>
+            <a:pPr>
               <a:spcBef>
-                <a:spcPts val="300"/>
+                <a:spcPts val="400"/>
               </a:spcBef>
-              <a:defRPr sz="950">
+              <a:defRPr sz="1050">
                 <a:solidFill>
                   <a:srgbClr val="475569"/>
                 </a:solidFill>
@@ -3584,39 +3587,7 @@
               </a:defRPr>
             </a:pPr>
             <a:r>
-              <a:t>• Split: 900 training, 100 evaluation samples</a:t>
-            </a:r>
-          </a:p>
-          <a:p>
-            <a:pPr algn="l">
-              <a:spcBef>
-                <a:spcPts val="300"/>
-              </a:spcBef>
-              <a:defRPr sz="950">
-                <a:solidFill>
-                  <a:srgbClr val="475569"/>
-                </a:solidFill>
-                <a:latin typeface="Calibri"/>
-              </a:defRPr>
-            </a:pPr>
-            <a:r>
-              <a:t>• Format: Formatted into Prompt templates: Instruction, Input, and Response</a:t>
-            </a:r>
-          </a:p>
-          <a:p>
-            <a:pPr algn="l">
-              <a:spcBef>
-                <a:spcPts val="300"/>
-              </a:spcBef>
-              <a:defRPr sz="950">
-                <a:solidFill>
-                  <a:srgbClr val="475569"/>
-                </a:solidFill>
-                <a:latin typeface="Calibri"/>
-              </a:defRPr>
-            </a:pPr>
-            <a:r>
-              <a:t>• Max Length: 512 tokens (optimized for local memory)</a:t>
+              <a:t>• Provide a cost-effective setup for local institutions and research environments.</a:t>
             </a:r>
           </a:p>
         </p:txBody>
@@ -3629,8 +3600,8 @@
         </p:nvSpPr>
         <p:spPr>
           <a:xfrm>
-            <a:off x="3392424" y="1920240"/>
-            <a:ext cx="2560320" cy="4114800"/>
+            <a:off x="4352544" y="1920240"/>
+            <a:ext cx="3474720" cy="3931920"/>
           </a:xfrm>
           <a:prstGeom prst="roundRect">
             <a:avLst/>
@@ -3674,8 +3645,8 @@
         </p:nvSpPr>
         <p:spPr>
           <a:xfrm>
-            <a:off x="3392424" y="1920240"/>
-            <a:ext cx="2560320" cy="109728"/>
+            <a:off x="4352544" y="1920240"/>
+            <a:ext cx="3474720" cy="109728"/>
           </a:xfrm>
           <a:prstGeom prst="rect">
             <a:avLst/>
@@ -3719,8 +3690,8 @@
         </p:nvSpPr>
         <p:spPr>
           <a:xfrm>
-            <a:off x="3529584" y="2148840"/>
-            <a:ext cx="2286000" cy="3749040"/>
+            <a:off x="4535424" y="2194560"/>
+            <a:ext cx="3108960" cy="3474720"/>
           </a:xfrm>
           <a:prstGeom prst="rect">
             <a:avLst/>
@@ -3753,7 +3724,7 @@
               <a:spcAft>
                 <a:spcPts val="800"/>
               </a:spcAft>
-              <a:defRPr sz="1600" b="1">
+              <a:defRPr sz="1800" b="1">
                 <a:solidFill>
                   <a:srgbClr val="0F172A"/>
                 </a:solidFill>
@@ -3761,15 +3732,15 @@
               </a:defRPr>
             </a:pPr>
             <a:r>
-              <a:t>Model Adaptation</a:t>
-            </a:r>
-          </a:p>
-          <a:p>
-            <a:pPr algn="l">
+              <a:t>Classroom-Ready Assistance</a:t>
+            </a:r>
+          </a:p>
+          <a:p>
+            <a:pPr>
               <a:spcBef>
-                <a:spcPts val="300"/>
+                <a:spcPts val="400"/>
               </a:spcBef>
-              <a:defRPr sz="950">
+              <a:defRPr sz="1050">
                 <a:solidFill>
                   <a:srgbClr val="475569"/>
                 </a:solidFill>
@@ -3777,15 +3748,15 @@
               </a:defRPr>
             </a:pPr>
             <a:r>
-              <a:t>• Base model: TinyLlama 1.1B (Chat-v1.0)</a:t>
-            </a:r>
-          </a:p>
-          <a:p>
-            <a:pPr algn="l">
+              <a:t>• Fine-tune the model specifically to answer educational queries.</a:t>
+            </a:r>
+          </a:p>
+          <a:p>
+            <a:pPr>
               <a:spcBef>
-                <a:spcPts val="300"/>
+                <a:spcPts val="400"/>
               </a:spcBef>
-              <a:defRPr sz="950">
+              <a:defRPr sz="1050">
                 <a:solidFill>
                   <a:srgbClr val="475569"/>
                 </a:solidFill>
@@ -3793,15 +3764,15 @@
               </a:defRPr>
             </a:pPr>
             <a:r>
-              <a:t>• Size: 1.1B parameters, decoder-only LLaMA</a:t>
-            </a:r>
-          </a:p>
-          <a:p>
-            <a:pPr algn="l">
+              <a:t>• Format responses to be clear, structured, and easy for students to understand.</a:t>
+            </a:r>
+          </a:p>
+          <a:p>
+            <a:pPr>
               <a:spcBef>
-                <a:spcPts val="300"/>
+                <a:spcPts val="400"/>
               </a:spcBef>
-              <a:defRPr sz="950">
+              <a:defRPr sz="1050">
                 <a:solidFill>
                   <a:srgbClr val="475569"/>
                 </a:solidFill>
@@ -3809,39 +3780,7 @@
               </a:defRPr>
             </a:pPr>
             <a:r>
-              <a:t>• Adaptation: LoRA (Low-Rank Adaptation) PEFT</a:t>
-            </a:r>
-          </a:p>
-          <a:p>
-            <a:pPr algn="l">
-              <a:spcBef>
-                <a:spcPts val="300"/>
-              </a:spcBef>
-              <a:defRPr sz="950">
-                <a:solidFill>
-                  <a:srgbClr val="475569"/>
-                </a:solidFill>
-                <a:latin typeface="Calibri"/>
-              </a:defRPr>
-            </a:pPr>
-            <a:r>
-              <a:t>• Target Modules: q_proj and v_proj</a:t>
-            </a:r>
-          </a:p>
-          <a:p>
-            <a:pPr algn="l">
-              <a:spcBef>
-                <a:spcPts val="300"/>
-              </a:spcBef>
-              <a:defRPr sz="950">
-                <a:solidFill>
-                  <a:srgbClr val="475569"/>
-                </a:solidFill>
-                <a:latin typeface="Calibri"/>
-              </a:defRPr>
-            </a:pPr>
-            <a:r>
-              <a:t>• Trainable params: 1.12 Million (only 0.1% of model)</a:t>
+              <a:t>• Encourage domain-specific accuracy and minimize general hallucinations.</a:t>
             </a:r>
           </a:p>
         </p:txBody>
@@ -3854,8 +3793,8 @@
         </p:nvSpPr>
         <p:spPr>
           <a:xfrm>
-            <a:off x="6236208" y="1920240"/>
-            <a:ext cx="2560320" cy="4114800"/>
+            <a:off x="8156448" y="1920240"/>
+            <a:ext cx="3474720" cy="3931920"/>
           </a:xfrm>
           <a:prstGeom prst="roundRect">
             <a:avLst/>
@@ -3899,8 +3838,8 @@
         </p:nvSpPr>
         <p:spPr>
           <a:xfrm>
-            <a:off x="6236208" y="1920240"/>
-            <a:ext cx="2560320" cy="109728"/>
+            <a:off x="8156448" y="1920240"/>
+            <a:ext cx="3474720" cy="109728"/>
           </a:xfrm>
           <a:prstGeom prst="rect">
             <a:avLst/>
@@ -3944,8 +3883,8 @@
         </p:nvSpPr>
         <p:spPr>
           <a:xfrm>
-            <a:off x="6373368" y="2148840"/>
-            <a:ext cx="2286000" cy="3749040"/>
+            <a:off x="8339328" y="2194560"/>
+            <a:ext cx="3108960" cy="3474720"/>
           </a:xfrm>
           <a:prstGeom prst="rect">
             <a:avLst/>
@@ -3978,7 +3917,7 @@
               <a:spcAft>
                 <a:spcPts val="800"/>
               </a:spcAft>
-              <a:defRPr sz="1600" b="1">
+              <a:defRPr sz="1800" b="1">
                 <a:solidFill>
                   <a:srgbClr val="0F172A"/>
                 </a:solidFill>
@@ -3986,15 +3925,15 @@
               </a:defRPr>
             </a:pPr>
             <a:r>
-              <a:t>CPU-Optimized Training</a:t>
-            </a:r>
-          </a:p>
-          <a:p>
-            <a:pPr algn="l">
+              <a:t>Privacy &amp; Offline Support</a:t>
+            </a:r>
+          </a:p>
+          <a:p>
+            <a:pPr>
               <a:spcBef>
-                <a:spcPts val="300"/>
+                <a:spcPts val="400"/>
               </a:spcBef>
-              <a:defRPr sz="950">
+              <a:defRPr sz="1050">
                 <a:solidFill>
                   <a:srgbClr val="475569"/>
                 </a:solidFill>
@@ -4002,15 +3941,15 @@
               </a:defRPr>
             </a:pPr>
             <a:r>
-              <a:t>• Device: CPU-only execution (zero GPU required)</a:t>
-            </a:r>
-          </a:p>
-          <a:p>
-            <a:pPr algn="l">
+              <a:t>• Establish a fully offline architecture.</a:t>
+            </a:r>
+          </a:p>
+          <a:p>
+            <a:pPr>
               <a:spcBef>
-                <a:spcPts val="300"/>
+                <a:spcPts val="400"/>
               </a:spcBef>
-              <a:defRPr sz="950">
+              <a:defRPr sz="1050">
                 <a:solidFill>
                   <a:srgbClr val="475569"/>
                 </a:solidFill>
@@ -4018,15 +3957,15 @@
               </a:defRPr>
             </a:pPr>
             <a:r>
-              <a:t>• Precision: Float32 for model stability on CPU</a:t>
-            </a:r>
-          </a:p>
-          <a:p>
-            <a:pPr algn="l">
+              <a:t>• Avoid sending student and teacher data to third-party cloud API services.</a:t>
+            </a:r>
+          </a:p>
+          <a:p>
+            <a:pPr>
               <a:spcBef>
-                <a:spcPts val="300"/>
+                <a:spcPts val="400"/>
               </a:spcBef>
-              <a:defRPr sz="950">
+              <a:defRPr sz="1050">
                 <a:solidFill>
                   <a:srgbClr val="475569"/>
                 </a:solidFill>
@@ -4034,248 +3973,7 @@
               </a:defRPr>
             </a:pPr>
             <a:r>
-              <a:t>• Batch size: 1 per device with gradient accumulation of 4 (effective batch = 4)</a:t>
-            </a:r>
-          </a:p>
-          <a:p>
-            <a:pPr algn="l">
-              <a:spcBef>
-                <a:spcPts val="300"/>
-              </a:spcBef>
-              <a:defRPr sz="950">
-                <a:solidFill>
-                  <a:srgbClr val="475569"/>
-                </a:solidFill>
-                <a:latin typeface="Calibri"/>
-              </a:defRPr>
-            </a:pPr>
-            <a:r>
-              <a:t>• Optimizer: AdamW (PyTorch CPU native)</a:t>
-            </a:r>
-          </a:p>
-          <a:p>
-            <a:pPr algn="l">
-              <a:spcBef>
-                <a:spcPts val="300"/>
-              </a:spcBef>
-              <a:defRPr sz="950">
-                <a:solidFill>
-                  <a:srgbClr val="475569"/>
-                </a:solidFill>
-                <a:latin typeface="Calibri"/>
-              </a:defRPr>
-            </a:pPr>
-            <a:r>
-              <a:t>• Technique: Gradient Checkpointing enabled</a:t>
-            </a:r>
-          </a:p>
-        </p:txBody>
-      </p:sp>
-      <p:sp>
-        <p:nvSpPr>
-          <p:cNvPr id="14" name="Rounded Rectangle 13"/>
-          <p:cNvSpPr/>
-          <p:nvPr/>
-        </p:nvSpPr>
-        <p:spPr>
-          <a:xfrm>
-            <a:off x="9079992" y="1920240"/>
-            <a:ext cx="2560320" cy="4114800"/>
-          </a:xfrm>
-          <a:prstGeom prst="roundRect">
-            <a:avLst/>
-          </a:prstGeom>
-          <a:solidFill>
-            <a:srgbClr val="FFFFFF"/>
-          </a:solidFill>
-          <a:ln w="19050">
-            <a:solidFill>
-              <a:srgbClr val="E2E8F0"/>
-            </a:solidFill>
-          </a:ln>
-        </p:spPr>
-        <p:style>
-          <a:lnRef idx="1">
-            <a:schemeClr val="accent1"/>
-          </a:lnRef>
-          <a:fillRef idx="3">
-            <a:schemeClr val="accent1"/>
-          </a:fillRef>
-          <a:effectRef idx="2">
-            <a:schemeClr val="accent1"/>
-          </a:effectRef>
-          <a:fontRef idx="minor">
-            <a:schemeClr val="lt1"/>
-          </a:fontRef>
-        </p:style>
-        <p:txBody>
-          <a:bodyPr rtlCol="0" anchor="ctr"/>
-          <a:lstStyle/>
-          <a:p>
-            <a:pPr algn="ctr"/>
-          </a:p>
-        </p:txBody>
-      </p:sp>
-      <p:sp>
-        <p:nvSpPr>
-          <p:cNvPr id="15" name="Rectangle 14"/>
-          <p:cNvSpPr/>
-          <p:nvPr/>
-        </p:nvSpPr>
-        <p:spPr>
-          <a:xfrm>
-            <a:off x="9079992" y="1920240"/>
-            <a:ext cx="2560320" cy="109728"/>
-          </a:xfrm>
-          <a:prstGeom prst="rect">
-            <a:avLst/>
-          </a:prstGeom>
-          <a:solidFill>
-            <a:srgbClr val="C5A059"/>
-          </a:solidFill>
-          <a:ln>
-            <a:solidFill>
-              <a:srgbClr val="C5A059"/>
-            </a:solidFill>
-          </a:ln>
-        </p:spPr>
-        <p:style>
-          <a:lnRef idx="1">
-            <a:schemeClr val="accent1"/>
-          </a:lnRef>
-          <a:fillRef idx="3">
-            <a:schemeClr val="accent1"/>
-          </a:fillRef>
-          <a:effectRef idx="2">
-            <a:schemeClr val="accent1"/>
-          </a:effectRef>
-          <a:fontRef idx="minor">
-            <a:schemeClr val="lt1"/>
-          </a:fontRef>
-        </p:style>
-        <p:txBody>
-          <a:bodyPr rtlCol="0" anchor="ctr"/>
-          <a:lstStyle/>
-          <a:p>
-            <a:pPr algn="ctr"/>
-          </a:p>
-        </p:txBody>
-      </p:sp>
-      <p:sp>
-        <p:nvSpPr>
-          <p:cNvPr id="16" name="TextBox 15"/>
-          <p:cNvSpPr txBox="1"/>
-          <p:nvPr/>
-        </p:nvSpPr>
-        <p:spPr>
-          <a:xfrm>
-            <a:off x="9217152" y="2148840"/>
-            <a:ext cx="2286000" cy="3749040"/>
-          </a:xfrm>
-          <a:prstGeom prst="rect">
-            <a:avLst/>
-          </a:prstGeom>
-          <a:noFill/>
-        </p:spPr>
-        <p:txBody>
-          <a:bodyPr wrap="square">
-            <a:spAutoFit/>
-          </a:bodyPr>
-          <a:lstStyle/>
-          <a:p>
-            <a:pPr>
-              <a:spcAft>
-                <a:spcPts val="200"/>
-              </a:spcAft>
-              <a:defRPr sz="2800" b="1">
-                <a:solidFill>
-                  <a:srgbClr val="C5A059"/>
-                </a:solidFill>
-                <a:latin typeface="Calibri"/>
-              </a:defRPr>
-            </a:pPr>
-            <a:r>
-              <a:t>04</a:t>
-            </a:r>
-          </a:p>
-          <a:p>
-            <a:pPr>
-              <a:spcAft>
-                <a:spcPts val="800"/>
-              </a:spcAft>
-              <a:defRPr sz="1600" b="1">
-                <a:solidFill>
-                  <a:srgbClr val="0F172A"/>
-                </a:solidFill>
-                <a:latin typeface="Calibri"/>
-              </a:defRPr>
-            </a:pPr>
-            <a:r>
-              <a:t>Streamlit App</a:t>
-            </a:r>
-          </a:p>
-          <a:p>
-            <a:pPr algn="l">
-              <a:spcBef>
-                <a:spcPts val="300"/>
-              </a:spcBef>
-              <a:defRPr sz="950">
-                <a:solidFill>
-                  <a:srgbClr val="475569"/>
-                </a:solidFill>
-                <a:latin typeface="Calibri"/>
-              </a:defRPr>
-            </a:pPr>
-            <a:r>
-              <a:t>• Weights: Adapter output saved to safetensors (~4.5MB)</a:t>
-            </a:r>
-          </a:p>
-          <a:p>
-            <a:pPr algn="l">
-              <a:spcBef>
-                <a:spcPts val="300"/>
-              </a:spcBef>
-              <a:defRPr sz="950">
-                <a:solidFill>
-                  <a:srgbClr val="475569"/>
-                </a:solidFill>
-                <a:latin typeface="Calibri"/>
-              </a:defRPr>
-            </a:pPr>
-            <a:r>
-              <a:t>• Interface: Streamlit web interface (app.py)</a:t>
-            </a:r>
-          </a:p>
-          <a:p>
-            <a:pPr algn="l">
-              <a:spcBef>
-                <a:spcPts val="300"/>
-              </a:spcBef>
-              <a:defRPr sz="950">
-                <a:solidFill>
-                  <a:srgbClr val="475569"/>
-                </a:solidFill>
-                <a:latin typeface="Calibri"/>
-              </a:defRPr>
-            </a:pPr>
-            <a:r>
-              <a:t>• Loading: Dynamic fallback to checkpoint-25 if final adapter is absent</a:t>
-            </a:r>
-          </a:p>
-          <a:p>
-            <a:pPr algn="l">
-              <a:spcBef>
-                <a:spcPts val="300"/>
-              </a:spcBef>
-              <a:defRPr sz="950">
-                <a:solidFill>
-                  <a:srgbClr val="475569"/>
-                </a:solidFill>
-                <a:latin typeface="Calibri"/>
-              </a:defRPr>
-            </a:pPr>
-            <a:r>
-              <a:t>• User prompt: Generates educational QA on the fly</a:t>
+              <a:t>• Enable deployment in remote areas with limited internet connectivity.</a:t>
             </a:r>
           </a:p>
         </p:txBody>
@@ -4337,7 +4035,7 @@
               </a:defRPr>
             </a:pPr>
             <a:r>
-              <a:t>METHOD &amp; PEFT CORE</a:t>
+              <a:t>DATASET &amp; PREPARATION</a:t>
             </a:r>
           </a:p>
         </p:txBody>
@@ -4373,7 +4071,7 @@
               </a:defRPr>
             </a:pPr>
             <a:r>
-              <a:t>Methodology: Low-Rank Adaptation (LoRA)</a:t>
+              <a:t>Alpaca Instruction Dataset</a:t>
             </a:r>
           </a:p>
         </p:txBody>
@@ -4409,7 +4107,7 @@
               </a:defRPr>
             </a:pPr>
             <a:r>
-              <a:t>Reducing trainable parameter count by 99.9% for high-efficiency adaptation on CPU hardware.</a:t>
+              <a:t>Utilizing Stanford's Alpaca instruction-following dataset for QA formatting.</a:t>
             </a:r>
           </a:p>
         </p:txBody>
@@ -4423,7 +4121,7 @@
         <p:spPr>
           <a:xfrm>
             <a:off x="548640" y="1920240"/>
-            <a:ext cx="5303520" cy="4206240"/>
+            <a:ext cx="5303520" cy="4114800"/>
           </a:xfrm>
           <a:prstGeom prst="rect">
             <a:avLst/>
@@ -4513,7 +4211,7 @@
         <p:spPr>
           <a:xfrm>
             <a:off x="822960" y="2194560"/>
-            <a:ext cx="4754880" cy="3657600"/>
+            <a:ext cx="4754880" cy="3566160"/>
           </a:xfrm>
           <a:prstGeom prst="rect">
             <a:avLst/>
@@ -4528,7 +4226,7 @@
           <a:p>
             <a:pPr>
               <a:spcAft>
-                <a:spcPts val="1400"/>
+                <a:spcPts val="1200"/>
               </a:spcAft>
               <a:defRPr sz="2000" b="1">
                 <a:solidFill>
@@ -4538,13 +4236,13 @@
               </a:defRPr>
             </a:pPr>
             <a:r>
-              <a:t>The Challenge: Full Parameter Tuning</a:t>
+              <a:t>Dataset Characteristics</a:t>
             </a:r>
           </a:p>
           <a:p>
             <a:pPr>
               <a:spcBef>
-                <a:spcPts val="800"/>
+                <a:spcPts val="600"/>
               </a:spcBef>
               <a:defRPr sz="1200">
                 <a:solidFill>
@@ -4554,13 +4252,13 @@
               </a:defRPr>
             </a:pPr>
             <a:r>
-              <a:t>• TinyLlama contains 1,101,174,784 parameters.</a:t>
+              <a:t>• Source: Stanford's tatsu-lab/alpaca on HuggingFace.</a:t>
             </a:r>
           </a:p>
           <a:p>
             <a:pPr>
               <a:spcBef>
-                <a:spcPts val="800"/>
+                <a:spcPts val="600"/>
               </a:spcBef>
               <a:defRPr sz="1200">
                 <a:solidFill>
@@ -4570,13 +4268,13 @@
               </a:defRPr>
             </a:pPr>
             <a:r>
-              <a:t>• Full fine-tuning updates every weight tensor, requiring gradients and optimizer states for all 1.1 Billion parameters.</a:t>
+              <a:t>• Total samples: 52,002 instruction-response pairs.</a:t>
             </a:r>
           </a:p>
           <a:p>
             <a:pPr>
               <a:spcBef>
-                <a:spcPts val="800"/>
+                <a:spcPts val="600"/>
               </a:spcBef>
               <a:defRPr sz="1200">
                 <a:solidFill>
@@ -4586,13 +4284,13 @@
               </a:defRPr>
             </a:pPr>
             <a:r>
-              <a:t>• GPU memory requirements exceed 24 GB for full float32 training, making laptop execution completely impossible.</a:t>
+              <a:t>• Subset size: 1,000 samples selected (optimized for laptop CPU resource constraints).</a:t>
             </a:r>
           </a:p>
           <a:p>
             <a:pPr>
               <a:spcBef>
-                <a:spcPts val="800"/>
+                <a:spcPts val="600"/>
               </a:spcBef>
               <a:defRPr sz="1200">
                 <a:solidFill>
@@ -4602,7 +4300,23 @@
               </a:defRPr>
             </a:pPr>
             <a:r>
-              <a:t>• CPU training without modification results in Out-Of-Memory (OOM) errors and extremely slow iteration times.</a:t>
+              <a:t>• Split structure: 900 samples (90%) for training, 100 samples (10%) for evaluation.</a:t>
+            </a:r>
+          </a:p>
+          <a:p>
+            <a:pPr>
+              <a:spcBef>
+                <a:spcPts val="600"/>
+              </a:spcBef>
+              <a:defRPr sz="1200">
+                <a:solidFill>
+                  <a:srgbClr val="475569"/>
+                </a:solidFill>
+                <a:latin typeface="Calibri"/>
+              </a:defRPr>
+            </a:pPr>
+            <a:r>
+              <a:t>• Tokenization: LLaMA tokenizer, padding to a maximum sequence length of 512 tokens.</a:t>
             </a:r>
           </a:p>
         </p:txBody>
@@ -4616,7 +4330,7 @@
         <p:spPr>
           <a:xfrm>
             <a:off x="6339535" y="1920240"/>
-            <a:ext cx="5303520" cy="4206240"/>
+            <a:ext cx="5303520" cy="4114800"/>
           </a:xfrm>
           <a:prstGeom prst="rect">
             <a:avLst/>
@@ -4706,7 +4420,7 @@
         <p:spPr>
           <a:xfrm>
             <a:off x="6613855" y="2194560"/>
-            <a:ext cx="4754880" cy="3657600"/>
+            <a:ext cx="4754880" cy="3566160"/>
           </a:xfrm>
           <a:prstGeom prst="rect">
             <a:avLst/>
@@ -4721,7 +4435,7 @@
           <a:p>
             <a:pPr>
               <a:spcAft>
-                <a:spcPts val="1400"/>
+                <a:spcPts val="1000"/>
               </a:spcAft>
               <a:defRPr sz="2000" b="1">
                 <a:solidFill>
@@ -4731,103 +4445,61 @@
               </a:defRPr>
             </a:pPr>
             <a:r>
-              <a:t>The PEFT Solution: Low-Rank Adaptation</a:t>
+              <a:t>Prompt Format Template</a:t>
+            </a:r>
+          </a:p>
+          <a:p>
+            <a:pPr>
+              <a:spcAft>
+                <a:spcPts val="1000"/>
+              </a:spcAft>
+              <a:defRPr sz="1200">
+                <a:solidFill>
+                  <a:srgbClr val="475569"/>
+                </a:solidFill>
+                <a:latin typeface="Calibri"/>
+              </a:defRPr>
+            </a:pPr>
+            <a:r>
+              <a:t>Data points are formatted into structured templates to construct unified context:</a:t>
             </a:r>
           </a:p>
           <a:p>
             <a:pPr>
               <a:spcBef>
-                <a:spcPts val="500"/>
+                <a:spcPts val="400"/>
               </a:spcBef>
-              <a:defRPr sz="1200">
-                <a:solidFill>
-                  <a:srgbClr val="475569"/>
-                </a:solidFill>
-                <a:latin typeface="Calibri"/>
-              </a:defRPr>
-            </a:pPr>
-            <a:r>
-              <a:t>• Freezes the pre-trained model weights (99.9% of base model remains unchanged).</a:t>
-            </a:r>
-          </a:p>
-          <a:p>
-            <a:pPr>
-              <a:spcBef>
-                <a:spcPts val="500"/>
-              </a:spcBef>
-              <a:defRPr sz="1200">
-                <a:solidFill>
-                  <a:srgbClr val="475569"/>
-                </a:solidFill>
-                <a:latin typeface="Calibri"/>
-              </a:defRPr>
-            </a:pPr>
-            <a:r>
-              <a:t>• Injects low-rank trainable decomposition matrices (A and B) into attention layers.</a:t>
-            </a:r>
-          </a:p>
-          <a:p>
-            <a:pPr>
-              <a:spcBef>
-                <a:spcPts val="500"/>
-              </a:spcBef>
-              <a:defRPr sz="1200">
-                <a:solidFill>
-                  <a:srgbClr val="475569"/>
-                </a:solidFill>
-                <a:latin typeface="Calibri"/>
-              </a:defRPr>
-            </a:pPr>
-            <a:r>
-              <a:t>• Target Modules: Query projection (q_proj) and Value projection (v_proj).</a:t>
-            </a:r>
-          </a:p>
-          <a:p>
-            <a:pPr>
-              <a:spcBef>
-                <a:spcPts val="500"/>
-              </a:spcBef>
-              <a:defRPr sz="1200">
-                <a:solidFill>
-                  <a:srgbClr val="475569"/>
-                </a:solidFill>
-                <a:latin typeface="Calibri"/>
-              </a:defRPr>
-            </a:pPr>
-            <a:r>
-              <a:t>• LoRA Hyperparameters: Rank (r) = 8, Alpha = 16, Dropout = 0.05.</a:t>
-            </a:r>
-          </a:p>
-          <a:p>
-            <a:pPr>
-              <a:spcBef>
-                <a:spcPts val="500"/>
-              </a:spcBef>
-              <a:defRPr sz="1200">
-                <a:solidFill>
-                  <a:srgbClr val="475569"/>
-                </a:solidFill>
-                <a:latin typeface="Calibri"/>
-              </a:defRPr>
-            </a:pPr>
-            <a:r>
-              <a:t>• Trainable parameters: 1,126,400 (just 0.1023% of total).</a:t>
-            </a:r>
-          </a:p>
-          <a:p>
-            <a:pPr>
-              <a:spcBef>
-                <a:spcPts val="500"/>
-              </a:spcBef>
-              <a:defRPr sz="1200">
-                <a:solidFill>
-                  <a:srgbClr val="475569"/>
-                </a:solidFill>
-                <a:latin typeface="Calibri"/>
-              </a:defRPr>
-            </a:pPr>
-            <a:r>
-              <a:t>• Storage footprint: Lightweight adapters weigh only 4.5 MB on disk.</a:t>
+              <a:defRPr sz="1100">
+                <a:solidFill>
+                  <a:srgbClr val="2563EB"/>
+                </a:solidFill>
+                <a:latin typeface="Courier New"/>
+              </a:defRPr>
+            </a:pPr>
+            <a:r>
+              <a:t>### Instruction:</a:t>
+            </a:r>
+            <a:br/>
+            <a:r>
+              <a:t>{instruction}</a:t>
+            </a:r>
+            <a:br/>
+            <a:br/>
+            <a:r>
+              <a:t>### Input:</a:t>
+            </a:r>
+            <a:br/>
+            <a:r>
+              <a:t>{input}    ← (Optional context, omitted if empty)</a:t>
+            </a:r>
+            <a:br/>
+            <a:br/>
+            <a:r>
+              <a:t>### Response:</a:t>
+            </a:r>
+            <a:br/>
+            <a:r>
+              <a:t>{output}</a:t>
             </a:r>
           </a:p>
         </p:txBody>
@@ -4889,7 +4561,7 @@
               </a:defRPr>
             </a:pPr>
             <a:r>
-              <a:t>SETUP &amp; RESULTS</a:t>
+              <a:t>WORKFLOW &amp; ARCHITECTURE</a:t>
             </a:r>
           </a:p>
         </p:txBody>
@@ -4925,7 +4597,7 @@
               </a:defRPr>
             </a:pPr>
             <a:r>
-              <a:t>Training Configuration &amp; Loss Performance</a:t>
+              <a:t>End-to-End Workflow &amp; System Architecture</a:t>
             </a:r>
           </a:p>
         </p:txBody>
@@ -4961,7 +4633,977 @@
               </a:defRPr>
             </a:pPr>
             <a:r>
-              <a:t>Detailed execution arguments and empirical training loss trends.</a:t>
+              <a:t>The systemic pipeline from raw data loading to interactive execution.</a:t>
+            </a:r>
+          </a:p>
+        </p:txBody>
+      </p:sp>
+      <p:sp>
+        <p:nvSpPr>
+          <p:cNvPr id="5" name="Rounded Rectangle 4"/>
+          <p:cNvSpPr/>
+          <p:nvPr/>
+        </p:nvSpPr>
+        <p:spPr>
+          <a:xfrm>
+            <a:off x="548640" y="1920240"/>
+            <a:ext cx="2560320" cy="4114800"/>
+          </a:xfrm>
+          <a:prstGeom prst="roundRect">
+            <a:avLst/>
+          </a:prstGeom>
+          <a:solidFill>
+            <a:srgbClr val="FFFFFF"/>
+          </a:solidFill>
+          <a:ln w="19050">
+            <a:solidFill>
+              <a:srgbClr val="E2E8F0"/>
+            </a:solidFill>
+          </a:ln>
+        </p:spPr>
+        <p:style>
+          <a:lnRef idx="1">
+            <a:schemeClr val="accent1"/>
+          </a:lnRef>
+          <a:fillRef idx="3">
+            <a:schemeClr val="accent1"/>
+          </a:fillRef>
+          <a:effectRef idx="2">
+            <a:schemeClr val="accent1"/>
+          </a:effectRef>
+          <a:fontRef idx="minor">
+            <a:schemeClr val="lt1"/>
+          </a:fontRef>
+        </p:style>
+        <p:txBody>
+          <a:bodyPr rtlCol="0" anchor="ctr"/>
+          <a:lstStyle/>
+          <a:p>
+            <a:pPr algn="ctr"/>
+          </a:p>
+        </p:txBody>
+      </p:sp>
+      <p:sp>
+        <p:nvSpPr>
+          <p:cNvPr id="6" name="Rectangle 5"/>
+          <p:cNvSpPr/>
+          <p:nvPr/>
+        </p:nvSpPr>
+        <p:spPr>
+          <a:xfrm>
+            <a:off x="548640" y="1920240"/>
+            <a:ext cx="2560320" cy="109728"/>
+          </a:xfrm>
+          <a:prstGeom prst="rect">
+            <a:avLst/>
+          </a:prstGeom>
+          <a:solidFill>
+            <a:srgbClr val="C5A059"/>
+          </a:solidFill>
+          <a:ln>
+            <a:solidFill>
+              <a:srgbClr val="C5A059"/>
+            </a:solidFill>
+          </a:ln>
+        </p:spPr>
+        <p:style>
+          <a:lnRef idx="1">
+            <a:schemeClr val="accent1"/>
+          </a:lnRef>
+          <a:fillRef idx="3">
+            <a:schemeClr val="accent1"/>
+          </a:fillRef>
+          <a:effectRef idx="2">
+            <a:schemeClr val="accent1"/>
+          </a:effectRef>
+          <a:fontRef idx="minor">
+            <a:schemeClr val="lt1"/>
+          </a:fontRef>
+        </p:style>
+        <p:txBody>
+          <a:bodyPr rtlCol="0" anchor="ctr"/>
+          <a:lstStyle/>
+          <a:p>
+            <a:pPr algn="ctr"/>
+          </a:p>
+        </p:txBody>
+      </p:sp>
+      <p:sp>
+        <p:nvSpPr>
+          <p:cNvPr id="7" name="TextBox 6"/>
+          <p:cNvSpPr txBox="1"/>
+          <p:nvPr/>
+        </p:nvSpPr>
+        <p:spPr>
+          <a:xfrm>
+            <a:off x="685800" y="2148840"/>
+            <a:ext cx="2286000" cy="3749040"/>
+          </a:xfrm>
+          <a:prstGeom prst="rect">
+            <a:avLst/>
+          </a:prstGeom>
+          <a:noFill/>
+        </p:spPr>
+        <p:txBody>
+          <a:bodyPr wrap="square">
+            <a:spAutoFit/>
+          </a:bodyPr>
+          <a:lstStyle/>
+          <a:p>
+            <a:pPr>
+              <a:spcAft>
+                <a:spcPts val="200"/>
+              </a:spcAft>
+              <a:defRPr sz="2800" b="1">
+                <a:solidFill>
+                  <a:srgbClr val="C5A059"/>
+                </a:solidFill>
+                <a:latin typeface="Calibri"/>
+              </a:defRPr>
+            </a:pPr>
+            <a:r>
+              <a:t>01</a:t>
+            </a:r>
+          </a:p>
+          <a:p>
+            <a:pPr>
+              <a:spcAft>
+                <a:spcPts val="800"/>
+              </a:spcAft>
+              <a:defRPr sz="1600" b="1">
+                <a:solidFill>
+                  <a:srgbClr val="0F172A"/>
+                </a:solidFill>
+                <a:latin typeface="Calibri"/>
+              </a:defRPr>
+            </a:pPr>
+            <a:r>
+              <a:t>Data Prep</a:t>
+            </a:r>
+          </a:p>
+          <a:p>
+            <a:pPr>
+              <a:spcBef>
+                <a:spcPts val="300"/>
+              </a:spcBef>
+              <a:defRPr sz="1000">
+                <a:solidFill>
+                  <a:srgbClr val="475569"/>
+                </a:solidFill>
+                <a:latin typeface="Calibri"/>
+              </a:defRPr>
+            </a:pPr>
+            <a:r>
+              <a:t>• Download Alpaca subset</a:t>
+            </a:r>
+          </a:p>
+          <a:p>
+            <a:pPr>
+              <a:spcBef>
+                <a:spcPts val="300"/>
+              </a:spcBef>
+              <a:defRPr sz="1000">
+                <a:solidFill>
+                  <a:srgbClr val="475569"/>
+                </a:solidFill>
+                <a:latin typeface="Calibri"/>
+              </a:defRPr>
+            </a:pPr>
+            <a:r>
+              <a:t>• Inject instruction template</a:t>
+            </a:r>
+          </a:p>
+          <a:p>
+            <a:pPr>
+              <a:spcBef>
+                <a:spcPts val="300"/>
+              </a:spcBef>
+              <a:defRPr sz="1000">
+                <a:solidFill>
+                  <a:srgbClr val="475569"/>
+                </a:solidFill>
+                <a:latin typeface="Calibri"/>
+              </a:defRPr>
+            </a:pPr>
+            <a:r>
+              <a:t>• Tokenize using LLaMA tokenizer</a:t>
+            </a:r>
+          </a:p>
+          <a:p>
+            <a:pPr>
+              <a:spcBef>
+                <a:spcPts val="300"/>
+              </a:spcBef>
+              <a:defRPr sz="1000">
+                <a:solidFill>
+                  <a:srgbClr val="475569"/>
+                </a:solidFill>
+                <a:latin typeface="Calibri"/>
+              </a:defRPr>
+            </a:pPr>
+            <a:r>
+              <a:t>• Apply padding &amp; truncate length to 512</a:t>
+            </a:r>
+          </a:p>
+        </p:txBody>
+      </p:sp>
+      <p:sp>
+        <p:nvSpPr>
+          <p:cNvPr id="8" name="Rounded Rectangle 7"/>
+          <p:cNvSpPr/>
+          <p:nvPr/>
+        </p:nvSpPr>
+        <p:spPr>
+          <a:xfrm>
+            <a:off x="3392424" y="1920240"/>
+            <a:ext cx="2560320" cy="4114800"/>
+          </a:xfrm>
+          <a:prstGeom prst="roundRect">
+            <a:avLst/>
+          </a:prstGeom>
+          <a:solidFill>
+            <a:srgbClr val="FFFFFF"/>
+          </a:solidFill>
+          <a:ln w="19050">
+            <a:solidFill>
+              <a:srgbClr val="E2E8F0"/>
+            </a:solidFill>
+          </a:ln>
+        </p:spPr>
+        <p:style>
+          <a:lnRef idx="1">
+            <a:schemeClr val="accent1"/>
+          </a:lnRef>
+          <a:fillRef idx="3">
+            <a:schemeClr val="accent1"/>
+          </a:fillRef>
+          <a:effectRef idx="2">
+            <a:schemeClr val="accent1"/>
+          </a:effectRef>
+          <a:fontRef idx="minor">
+            <a:schemeClr val="lt1"/>
+          </a:fontRef>
+        </p:style>
+        <p:txBody>
+          <a:bodyPr rtlCol="0" anchor="ctr"/>
+          <a:lstStyle/>
+          <a:p>
+            <a:pPr algn="ctr"/>
+          </a:p>
+        </p:txBody>
+      </p:sp>
+      <p:sp>
+        <p:nvSpPr>
+          <p:cNvPr id="9" name="Rectangle 8"/>
+          <p:cNvSpPr/>
+          <p:nvPr/>
+        </p:nvSpPr>
+        <p:spPr>
+          <a:xfrm>
+            <a:off x="3392424" y="1920240"/>
+            <a:ext cx="2560320" cy="109728"/>
+          </a:xfrm>
+          <a:prstGeom prst="rect">
+            <a:avLst/>
+          </a:prstGeom>
+          <a:solidFill>
+            <a:srgbClr val="C5A059"/>
+          </a:solidFill>
+          <a:ln>
+            <a:solidFill>
+              <a:srgbClr val="C5A059"/>
+            </a:solidFill>
+          </a:ln>
+        </p:spPr>
+        <p:style>
+          <a:lnRef idx="1">
+            <a:schemeClr val="accent1"/>
+          </a:lnRef>
+          <a:fillRef idx="3">
+            <a:schemeClr val="accent1"/>
+          </a:fillRef>
+          <a:effectRef idx="2">
+            <a:schemeClr val="accent1"/>
+          </a:effectRef>
+          <a:fontRef idx="minor">
+            <a:schemeClr val="lt1"/>
+          </a:fontRef>
+        </p:style>
+        <p:txBody>
+          <a:bodyPr rtlCol="0" anchor="ctr"/>
+          <a:lstStyle/>
+          <a:p>
+            <a:pPr algn="ctr"/>
+          </a:p>
+        </p:txBody>
+      </p:sp>
+      <p:sp>
+        <p:nvSpPr>
+          <p:cNvPr id="10" name="TextBox 9"/>
+          <p:cNvSpPr txBox="1"/>
+          <p:nvPr/>
+        </p:nvSpPr>
+        <p:spPr>
+          <a:xfrm>
+            <a:off x="3529584" y="2148840"/>
+            <a:ext cx="2286000" cy="3749040"/>
+          </a:xfrm>
+          <a:prstGeom prst="rect">
+            <a:avLst/>
+          </a:prstGeom>
+          <a:noFill/>
+        </p:spPr>
+        <p:txBody>
+          <a:bodyPr wrap="square">
+            <a:spAutoFit/>
+          </a:bodyPr>
+          <a:lstStyle/>
+          <a:p>
+            <a:pPr>
+              <a:spcAft>
+                <a:spcPts val="200"/>
+              </a:spcAft>
+              <a:defRPr sz="2800" b="1">
+                <a:solidFill>
+                  <a:srgbClr val="C5A059"/>
+                </a:solidFill>
+                <a:latin typeface="Calibri"/>
+              </a:defRPr>
+            </a:pPr>
+            <a:r>
+              <a:t>02</a:t>
+            </a:r>
+          </a:p>
+          <a:p>
+            <a:pPr>
+              <a:spcAft>
+                <a:spcPts val="800"/>
+              </a:spcAft>
+              <a:defRPr sz="1600" b="1">
+                <a:solidFill>
+                  <a:srgbClr val="0F172A"/>
+                </a:solidFill>
+                <a:latin typeface="Calibri"/>
+              </a:defRPr>
+            </a:pPr>
+            <a:r>
+              <a:t>PEFT Configuration</a:t>
+            </a:r>
+          </a:p>
+          <a:p>
+            <a:pPr>
+              <a:spcBef>
+                <a:spcPts val="300"/>
+              </a:spcBef>
+              <a:defRPr sz="1000">
+                <a:solidFill>
+                  <a:srgbClr val="475569"/>
+                </a:solidFill>
+                <a:latin typeface="Calibri"/>
+              </a:defRPr>
+            </a:pPr>
+            <a:r>
+              <a:t>• Load base TinyLlama 1.1B</a:t>
+            </a:r>
+          </a:p>
+          <a:p>
+            <a:pPr>
+              <a:spcBef>
+                <a:spcPts val="300"/>
+              </a:spcBef>
+              <a:defRPr sz="1000">
+                <a:solidFill>
+                  <a:srgbClr val="475569"/>
+                </a:solidFill>
+                <a:latin typeface="Calibri"/>
+              </a:defRPr>
+            </a:pPr>
+            <a:r>
+              <a:t>• Freeze 99.9% of base model weights</a:t>
+            </a:r>
+          </a:p>
+          <a:p>
+            <a:pPr>
+              <a:spcBef>
+                <a:spcPts val="300"/>
+              </a:spcBef>
+              <a:defRPr sz="1000">
+                <a:solidFill>
+                  <a:srgbClr val="475569"/>
+                </a:solidFill>
+                <a:latin typeface="Calibri"/>
+              </a:defRPr>
+            </a:pPr>
+            <a:r>
+              <a:t>• Apply LoRA adapters</a:t>
+            </a:r>
+          </a:p>
+          <a:p>
+            <a:pPr>
+              <a:spcBef>
+                <a:spcPts val="300"/>
+              </a:spcBef>
+              <a:defRPr sz="1000">
+                <a:solidFill>
+                  <a:srgbClr val="475569"/>
+                </a:solidFill>
+                <a:latin typeface="Calibri"/>
+              </a:defRPr>
+            </a:pPr>
+            <a:r>
+              <a:t>• Target q_proj &amp; v_proj (r=8, alpha=16)</a:t>
+            </a:r>
+          </a:p>
+        </p:txBody>
+      </p:sp>
+      <p:sp>
+        <p:nvSpPr>
+          <p:cNvPr id="11" name="Rounded Rectangle 10"/>
+          <p:cNvSpPr/>
+          <p:nvPr/>
+        </p:nvSpPr>
+        <p:spPr>
+          <a:xfrm>
+            <a:off x="6236208" y="1920240"/>
+            <a:ext cx="2560320" cy="4114800"/>
+          </a:xfrm>
+          <a:prstGeom prst="roundRect">
+            <a:avLst/>
+          </a:prstGeom>
+          <a:solidFill>
+            <a:srgbClr val="FFFFFF"/>
+          </a:solidFill>
+          <a:ln w="19050">
+            <a:solidFill>
+              <a:srgbClr val="E2E8F0"/>
+            </a:solidFill>
+          </a:ln>
+        </p:spPr>
+        <p:style>
+          <a:lnRef idx="1">
+            <a:schemeClr val="accent1"/>
+          </a:lnRef>
+          <a:fillRef idx="3">
+            <a:schemeClr val="accent1"/>
+          </a:fillRef>
+          <a:effectRef idx="2">
+            <a:schemeClr val="accent1"/>
+          </a:effectRef>
+          <a:fontRef idx="minor">
+            <a:schemeClr val="lt1"/>
+          </a:fontRef>
+        </p:style>
+        <p:txBody>
+          <a:bodyPr rtlCol="0" anchor="ctr"/>
+          <a:lstStyle/>
+          <a:p>
+            <a:pPr algn="ctr"/>
+          </a:p>
+        </p:txBody>
+      </p:sp>
+      <p:sp>
+        <p:nvSpPr>
+          <p:cNvPr id="12" name="Rectangle 11"/>
+          <p:cNvSpPr/>
+          <p:nvPr/>
+        </p:nvSpPr>
+        <p:spPr>
+          <a:xfrm>
+            <a:off x="6236208" y="1920240"/>
+            <a:ext cx="2560320" cy="109728"/>
+          </a:xfrm>
+          <a:prstGeom prst="rect">
+            <a:avLst/>
+          </a:prstGeom>
+          <a:solidFill>
+            <a:srgbClr val="C5A059"/>
+          </a:solidFill>
+          <a:ln>
+            <a:solidFill>
+              <a:srgbClr val="C5A059"/>
+            </a:solidFill>
+          </a:ln>
+        </p:spPr>
+        <p:style>
+          <a:lnRef idx="1">
+            <a:schemeClr val="accent1"/>
+          </a:lnRef>
+          <a:fillRef idx="3">
+            <a:schemeClr val="accent1"/>
+          </a:fillRef>
+          <a:effectRef idx="2">
+            <a:schemeClr val="accent1"/>
+          </a:effectRef>
+          <a:fontRef idx="minor">
+            <a:schemeClr val="lt1"/>
+          </a:fontRef>
+        </p:style>
+        <p:txBody>
+          <a:bodyPr rtlCol="0" anchor="ctr"/>
+          <a:lstStyle/>
+          <a:p>
+            <a:pPr algn="ctr"/>
+          </a:p>
+        </p:txBody>
+      </p:sp>
+      <p:sp>
+        <p:nvSpPr>
+          <p:cNvPr id="13" name="TextBox 12"/>
+          <p:cNvSpPr txBox="1"/>
+          <p:nvPr/>
+        </p:nvSpPr>
+        <p:spPr>
+          <a:xfrm>
+            <a:off x="6373368" y="2148840"/>
+            <a:ext cx="2286000" cy="3749040"/>
+          </a:xfrm>
+          <a:prstGeom prst="rect">
+            <a:avLst/>
+          </a:prstGeom>
+          <a:noFill/>
+        </p:spPr>
+        <p:txBody>
+          <a:bodyPr wrap="square">
+            <a:spAutoFit/>
+          </a:bodyPr>
+          <a:lstStyle/>
+          <a:p>
+            <a:pPr>
+              <a:spcAft>
+                <a:spcPts val="200"/>
+              </a:spcAft>
+              <a:defRPr sz="2800" b="1">
+                <a:solidFill>
+                  <a:srgbClr val="C5A059"/>
+                </a:solidFill>
+                <a:latin typeface="Calibri"/>
+              </a:defRPr>
+            </a:pPr>
+            <a:r>
+              <a:t>03</a:t>
+            </a:r>
+          </a:p>
+          <a:p>
+            <a:pPr>
+              <a:spcAft>
+                <a:spcPts val="800"/>
+              </a:spcAft>
+              <a:defRPr sz="1600" b="1">
+                <a:solidFill>
+                  <a:srgbClr val="0F172A"/>
+                </a:solidFill>
+                <a:latin typeface="Calibri"/>
+              </a:defRPr>
+            </a:pPr>
+            <a:r>
+              <a:t>CPU-Only Training</a:t>
+            </a:r>
+          </a:p>
+          <a:p>
+            <a:pPr>
+              <a:spcBef>
+                <a:spcPts val="300"/>
+              </a:spcBef>
+              <a:defRPr sz="1000">
+                <a:solidFill>
+                  <a:srgbClr val="475569"/>
+                </a:solidFill>
+                <a:latin typeface="Calibri"/>
+              </a:defRPr>
+            </a:pPr>
+            <a:r>
+              <a:t>• PyTorch CPU-only runtime</a:t>
+            </a:r>
+          </a:p>
+          <a:p>
+            <a:pPr>
+              <a:spcBef>
+                <a:spcPts val="300"/>
+              </a:spcBef>
+              <a:defRPr sz="1000">
+                <a:solidFill>
+                  <a:srgbClr val="475569"/>
+                </a:solidFill>
+                <a:latin typeface="Calibri"/>
+              </a:defRPr>
+            </a:pPr>
+            <a:r>
+              <a:t>• Use Float32 training precision</a:t>
+            </a:r>
+          </a:p>
+          <a:p>
+            <a:pPr>
+              <a:spcBef>
+                <a:spcPts val="300"/>
+              </a:spcBef>
+              <a:defRPr sz="1000">
+                <a:solidFill>
+                  <a:srgbClr val="475569"/>
+                </a:solidFill>
+                <a:latin typeface="Calibri"/>
+              </a:defRPr>
+            </a:pPr>
+            <a:r>
+              <a:t>• Enable Gradient Checkpointing</a:t>
+            </a:r>
+          </a:p>
+          <a:p>
+            <a:pPr>
+              <a:spcBef>
+                <a:spcPts val="300"/>
+              </a:spcBef>
+              <a:defRPr sz="1000">
+                <a:solidFill>
+                  <a:srgbClr val="475569"/>
+                </a:solidFill>
+                <a:latin typeface="Calibri"/>
+              </a:defRPr>
+            </a:pPr>
+            <a:r>
+              <a:t>• Apply AdamW (Effective Batch Size = 4)</a:t>
+            </a:r>
+          </a:p>
+        </p:txBody>
+      </p:sp>
+      <p:sp>
+        <p:nvSpPr>
+          <p:cNvPr id="14" name="Rounded Rectangle 13"/>
+          <p:cNvSpPr/>
+          <p:nvPr/>
+        </p:nvSpPr>
+        <p:spPr>
+          <a:xfrm>
+            <a:off x="9079992" y="1920240"/>
+            <a:ext cx="2560320" cy="4114800"/>
+          </a:xfrm>
+          <a:prstGeom prst="roundRect">
+            <a:avLst/>
+          </a:prstGeom>
+          <a:solidFill>
+            <a:srgbClr val="FFFFFF"/>
+          </a:solidFill>
+          <a:ln w="19050">
+            <a:solidFill>
+              <a:srgbClr val="E2E8F0"/>
+            </a:solidFill>
+          </a:ln>
+        </p:spPr>
+        <p:style>
+          <a:lnRef idx="1">
+            <a:schemeClr val="accent1"/>
+          </a:lnRef>
+          <a:fillRef idx="3">
+            <a:schemeClr val="accent1"/>
+          </a:fillRef>
+          <a:effectRef idx="2">
+            <a:schemeClr val="accent1"/>
+          </a:effectRef>
+          <a:fontRef idx="minor">
+            <a:schemeClr val="lt1"/>
+          </a:fontRef>
+        </p:style>
+        <p:txBody>
+          <a:bodyPr rtlCol="0" anchor="ctr"/>
+          <a:lstStyle/>
+          <a:p>
+            <a:pPr algn="ctr"/>
+          </a:p>
+        </p:txBody>
+      </p:sp>
+      <p:sp>
+        <p:nvSpPr>
+          <p:cNvPr id="15" name="Rectangle 14"/>
+          <p:cNvSpPr/>
+          <p:nvPr/>
+        </p:nvSpPr>
+        <p:spPr>
+          <a:xfrm>
+            <a:off x="9079992" y="1920240"/>
+            <a:ext cx="2560320" cy="109728"/>
+          </a:xfrm>
+          <a:prstGeom prst="rect">
+            <a:avLst/>
+          </a:prstGeom>
+          <a:solidFill>
+            <a:srgbClr val="C5A059"/>
+          </a:solidFill>
+          <a:ln>
+            <a:solidFill>
+              <a:srgbClr val="C5A059"/>
+            </a:solidFill>
+          </a:ln>
+        </p:spPr>
+        <p:style>
+          <a:lnRef idx="1">
+            <a:schemeClr val="accent1"/>
+          </a:lnRef>
+          <a:fillRef idx="3">
+            <a:schemeClr val="accent1"/>
+          </a:fillRef>
+          <a:effectRef idx="2">
+            <a:schemeClr val="accent1"/>
+          </a:effectRef>
+          <a:fontRef idx="minor">
+            <a:schemeClr val="lt1"/>
+          </a:fontRef>
+        </p:style>
+        <p:txBody>
+          <a:bodyPr rtlCol="0" anchor="ctr"/>
+          <a:lstStyle/>
+          <a:p>
+            <a:pPr algn="ctr"/>
+          </a:p>
+        </p:txBody>
+      </p:sp>
+      <p:sp>
+        <p:nvSpPr>
+          <p:cNvPr id="16" name="TextBox 15"/>
+          <p:cNvSpPr txBox="1"/>
+          <p:nvPr/>
+        </p:nvSpPr>
+        <p:spPr>
+          <a:xfrm>
+            <a:off x="9217152" y="2148840"/>
+            <a:ext cx="2286000" cy="3749040"/>
+          </a:xfrm>
+          <a:prstGeom prst="rect">
+            <a:avLst/>
+          </a:prstGeom>
+          <a:noFill/>
+        </p:spPr>
+        <p:txBody>
+          <a:bodyPr wrap="square">
+            <a:spAutoFit/>
+          </a:bodyPr>
+          <a:lstStyle/>
+          <a:p>
+            <a:pPr>
+              <a:spcAft>
+                <a:spcPts val="200"/>
+              </a:spcAft>
+              <a:defRPr sz="2800" b="1">
+                <a:solidFill>
+                  <a:srgbClr val="C5A059"/>
+                </a:solidFill>
+                <a:latin typeface="Calibri"/>
+              </a:defRPr>
+            </a:pPr>
+            <a:r>
+              <a:t>04</a:t>
+            </a:r>
+          </a:p>
+          <a:p>
+            <a:pPr>
+              <a:spcAft>
+                <a:spcPts val="800"/>
+              </a:spcAft>
+              <a:defRPr sz="1600" b="1">
+                <a:solidFill>
+                  <a:srgbClr val="0F172A"/>
+                </a:solidFill>
+                <a:latin typeface="Calibri"/>
+              </a:defRPr>
+            </a:pPr>
+            <a:r>
+              <a:t>Local Web UI</a:t>
+            </a:r>
+          </a:p>
+          <a:p>
+            <a:pPr>
+              <a:spcBef>
+                <a:spcPts val="300"/>
+              </a:spcBef>
+              <a:defRPr sz="1000">
+                <a:solidFill>
+                  <a:srgbClr val="475569"/>
+                </a:solidFill>
+                <a:latin typeface="Calibri"/>
+              </a:defRPr>
+            </a:pPr>
+            <a:r>
+              <a:t>• Save adapter weights (~4.5MB)</a:t>
+            </a:r>
+          </a:p>
+          <a:p>
+            <a:pPr>
+              <a:spcBef>
+                <a:spcPts val="300"/>
+              </a:spcBef>
+              <a:defRPr sz="1000">
+                <a:solidFill>
+                  <a:srgbClr val="475569"/>
+                </a:solidFill>
+                <a:latin typeface="Calibri"/>
+              </a:defRPr>
+            </a:pPr>
+            <a:r>
+              <a:t>• Integrate with Streamlit App</a:t>
+            </a:r>
+          </a:p>
+          <a:p>
+            <a:pPr>
+              <a:spcBef>
+                <a:spcPts val="300"/>
+              </a:spcBef>
+              <a:defRPr sz="1000">
+                <a:solidFill>
+                  <a:srgbClr val="475569"/>
+                </a:solidFill>
+                <a:latin typeface="Calibri"/>
+              </a:defRPr>
+            </a:pPr>
+            <a:r>
+              <a:t>• Auto-detect adapter directory checkpoints</a:t>
+            </a:r>
+          </a:p>
+          <a:p>
+            <a:pPr>
+              <a:spcBef>
+                <a:spcPts val="300"/>
+              </a:spcBef>
+              <a:defRPr sz="1000">
+                <a:solidFill>
+                  <a:srgbClr val="475569"/>
+                </a:solidFill>
+                <a:latin typeface="Calibri"/>
+              </a:defRPr>
+            </a:pPr>
+            <a:r>
+              <a:t>• Generate response on CPU in browser</a:t>
+            </a:r>
+          </a:p>
+        </p:txBody>
+      </p:sp>
+    </p:spTree>
+  </p:cSld>
+  <p:clrMapOvr>
+    <a:masterClrMapping/>
+  </p:clrMapOvr>
+</p:sld>
+</file>
+
+<file path=ppt/slides/slide5.xml><?xml version="1.0" encoding="utf-8"?>
+<p:sld xmlns:a="http://schemas.openxmlformats.org/drawingml/2006/main" xmlns:p="http://schemas.openxmlformats.org/presentationml/2006/main" xmlns:r="http://schemas.openxmlformats.org/officeDocument/2006/relationships">
+  <p:cSld>
+    <p:bg>
+      <p:bgPr>
+        <a:solidFill>
+          <a:srgbClr val="F8FAFC"/>
+        </a:solidFill>
+        <a:effectLst/>
+      </p:bgPr>
+    </p:bg>
+    <p:spTree>
+      <p:nvGrpSpPr>
+        <p:cNvPr id="1" name=""/>
+        <p:cNvGrpSpPr/>
+        <p:nvPr/>
+      </p:nvGrpSpPr>
+      <p:grpSpPr/>
+      <p:sp>
+        <p:nvSpPr>
+          <p:cNvPr id="2" name="TextBox 1"/>
+          <p:cNvSpPr txBox="1"/>
+          <p:nvPr/>
+        </p:nvSpPr>
+        <p:spPr>
+          <a:xfrm>
+            <a:off x="548640" y="365760"/>
+            <a:ext cx="11094415" cy="274320"/>
+          </a:xfrm>
+          <a:prstGeom prst="rect">
+            <a:avLst/>
+          </a:prstGeom>
+          <a:noFill/>
+        </p:spPr>
+        <p:txBody>
+          <a:bodyPr wrap="square" lIns="0" rIns="0" tIns="0" bIns="0">
+            <a:spAutoFit/>
+          </a:bodyPr>
+          <a:lstStyle/>
+          <a:p>
+            <a:pPr>
+              <a:defRPr sz="1000" b="1">
+                <a:solidFill>
+                  <a:srgbClr val="C5A059"/>
+                </a:solidFill>
+                <a:latin typeface="Calibri"/>
+              </a:defRPr>
+            </a:pPr>
+            <a:r>
+              <a:t>CHALLENGES &amp; SOLUTIONS</a:t>
+            </a:r>
+          </a:p>
+        </p:txBody>
+      </p:sp>
+      <p:sp>
+        <p:nvSpPr>
+          <p:cNvPr id="3" name="TextBox 2"/>
+          <p:cNvSpPr txBox="1"/>
+          <p:nvPr/>
+        </p:nvSpPr>
+        <p:spPr>
+          <a:xfrm>
+            <a:off x="548640" y="640080"/>
+            <a:ext cx="11094415" cy="731520"/>
+          </a:xfrm>
+          <a:prstGeom prst="rect">
+            <a:avLst/>
+          </a:prstGeom>
+          <a:noFill/>
+        </p:spPr>
+        <p:txBody>
+          <a:bodyPr wrap="square" lIns="0" rIns="0" tIns="0" bIns="0">
+            <a:spAutoFit/>
+          </a:bodyPr>
+          <a:lstStyle/>
+          <a:p>
+            <a:pPr>
+              <a:defRPr sz="3200" b="1">
+                <a:solidFill>
+                  <a:srgbClr val="0F172A"/>
+                </a:solidFill>
+                <a:latin typeface="Calibri"/>
+              </a:defRPr>
+            </a:pPr>
+            <a:r>
+              <a:t>Development Challenges &amp; Key Solutions</a:t>
+            </a:r>
+          </a:p>
+        </p:txBody>
+      </p:sp>
+      <p:sp>
+        <p:nvSpPr>
+          <p:cNvPr id="4" name="TextBox 3"/>
+          <p:cNvSpPr txBox="1"/>
+          <p:nvPr/>
+        </p:nvSpPr>
+        <p:spPr>
+          <a:xfrm>
+            <a:off x="548640" y="1371600"/>
+            <a:ext cx="11094415" cy="365760"/>
+          </a:xfrm>
+          <a:prstGeom prst="rect">
+            <a:avLst/>
+          </a:prstGeom>
+          <a:noFill/>
+        </p:spPr>
+        <p:txBody>
+          <a:bodyPr wrap="none">
+            <a:spAutoFit/>
+          </a:bodyPr>
+          <a:lstStyle/>
+          <a:p>
+            <a:pPr>
+              <a:defRPr sz="1500">
+                <a:solidFill>
+                  <a:srgbClr val="475569"/>
+                </a:solidFill>
+                <a:latin typeface="Calibri"/>
+              </a:defRPr>
+            </a:pPr>
+            <a:r>
+              <a:t>Overcoming hardware bottlenecks and path resolution errors on local client machines.</a:t>
             </a:r>
           </a:p>
         </p:txBody>
@@ -4975,7 +5617,7 @@
         <p:spPr>
           <a:xfrm>
             <a:off x="548640" y="1920240"/>
-            <a:ext cx="5303520" cy="4206240"/>
+            <a:ext cx="5303520" cy="4114800"/>
           </a:xfrm>
           <a:prstGeom prst="rect">
             <a:avLst/>
@@ -5026,11 +5668,11 @@
             <a:avLst/>
           </a:prstGeom>
           <a:solidFill>
-            <a:srgbClr val="0F172A"/>
+            <a:srgbClr val="475569"/>
           </a:solidFill>
           <a:ln>
             <a:solidFill>
-              <a:srgbClr val="0F172A"/>
+              <a:srgbClr val="475569"/>
             </a:solidFill>
           </a:ln>
         </p:spPr>
@@ -5065,7 +5707,7 @@
         <p:spPr>
           <a:xfrm>
             <a:off x="822960" y="2194560"/>
-            <a:ext cx="4754880" cy="3657600"/>
+            <a:ext cx="4754880" cy="3566160"/>
           </a:xfrm>
           <a:prstGeom prst="rect">
             <a:avLst/>
@@ -5090,7 +5732,7 @@
               </a:defRPr>
             </a:pPr>
             <a:r>
-              <a:t>Training Arguments (CPU Optimized)</a:t>
+              <a:t>1. Severe CPU Memory Constraints</a:t>
             </a:r>
           </a:p>
           <a:p>
@@ -5098,7 +5740,7 @@
               <a:spcBef>
                 <a:spcPts val="600"/>
               </a:spcBef>
-              <a:defRPr sz="1200">
+              <a:defRPr sz="1100">
                 <a:solidFill>
                   <a:srgbClr val="475569"/>
                 </a:solidFill>
@@ -5106,7 +5748,7 @@
               </a:defRPr>
             </a:pPr>
             <a:r>
-              <a:t>• Device: Forced CPU (use_cpu=True)</a:t>
+              <a:t>• Challenge: Loading a 1.1B model and performing backpropagation consumes huge RAM, causing standard CPUs to throw Out-Of-Memory (OOM) errors.</a:t>
             </a:r>
           </a:p>
           <a:p>
@@ -5114,7 +5756,7 @@
               <a:spcBef>
                 <a:spcPts val="600"/>
               </a:spcBef>
-              <a:defRPr sz="1200">
+              <a:defRPr sz="1100">
                 <a:solidFill>
                   <a:srgbClr val="475569"/>
                 </a:solidFill>
@@ -5122,7 +5764,7 @@
               </a:defRPr>
             </a:pPr>
             <a:r>
-              <a:t>• Precision: Float32 (no FP16/BF16 on CPU)</a:t>
+              <a:t>• Solution: Enabled gradient checkpointing to discard intermediate activations.</a:t>
             </a:r>
           </a:p>
           <a:p>
@@ -5130,7 +5772,7 @@
               <a:spcBef>
                 <a:spcPts val="600"/>
               </a:spcBef>
-              <a:defRPr sz="1200">
+              <a:defRPr sz="1100">
                 <a:solidFill>
                   <a:srgbClr val="475569"/>
                 </a:solidFill>
@@ -5138,7 +5780,7 @@
               </a:defRPr>
             </a:pPr>
             <a:r>
-              <a:t>• Batch Size: 1 sample per device</a:t>
+              <a:t>• Solution: Used Parameter-Efficient Fine-Tuning (PEFT) with LoRA, shrinking trainable parameters to 0.1% (~1.12M), lowering peak RAM to ~6 GB.</a:t>
             </a:r>
           </a:p>
           <a:p>
@@ -5146,7 +5788,7 @@
               <a:spcBef>
                 <a:spcPts val="600"/>
               </a:spcBef>
-              <a:defRPr sz="1200">
+              <a:defRPr sz="1100">
                 <a:solidFill>
                   <a:srgbClr val="475569"/>
                 </a:solidFill>
@@ -5154,71 +5796,7 @@
               </a:defRPr>
             </a:pPr>
             <a:r>
-              <a:t>• Gradient Accumulation: 4 steps (Effective Batch Size = 4)</a:t>
-            </a:r>
-          </a:p>
-          <a:p>
-            <a:pPr>
-              <a:spcBef>
-                <a:spcPts val="600"/>
-              </a:spcBef>
-              <a:defRPr sz="1200">
-                <a:solidFill>
-                  <a:srgbClr val="475569"/>
-                </a:solidFill>
-                <a:latin typeface="Calibri"/>
-              </a:defRPr>
-            </a:pPr>
-            <a:r>
-              <a:t>• Optimizer: AdamW (PyTorch native CPU)</a:t>
-            </a:r>
-          </a:p>
-          <a:p>
-            <a:pPr>
-              <a:spcBef>
-                <a:spcPts val="600"/>
-              </a:spcBef>
-              <a:defRPr sz="1200">
-                <a:solidFill>
-                  <a:srgbClr val="475569"/>
-                </a:solidFill>
-                <a:latin typeface="Calibri"/>
-              </a:defRPr>
-            </a:pPr>
-            <a:r>
-              <a:t>• Learning Rate: 2e-4 (Constant scheduler, Warmup steps = 5)</a:t>
-            </a:r>
-          </a:p>
-          <a:p>
-            <a:pPr>
-              <a:spcBef>
-                <a:spcPts val="600"/>
-              </a:spcBef>
-              <a:defRPr sz="1200">
-                <a:solidFill>
-                  <a:srgbClr val="475569"/>
-                </a:solidFill>
-                <a:latin typeface="Calibri"/>
-              </a:defRPr>
-            </a:pPr>
-            <a:r>
-              <a:t>• Gradient Checkpointing: Enabled to minimize CPU RAM</a:t>
-            </a:r>
-          </a:p>
-          <a:p>
-            <a:pPr>
-              <a:spcBef>
-                <a:spcPts val="600"/>
-              </a:spcBef>
-              <a:defRPr sz="1200">
-                <a:solidFill>
-                  <a:srgbClr val="475569"/>
-                </a:solidFill>
-                <a:latin typeface="Calibri"/>
-              </a:defRPr>
-            </a:pPr>
-            <a:r>
-              <a:t>• Save Strategy: Saves checkpoint every 25 steps</a:t>
+              <a:t>• Solution: Restricted training batch size to 1, while using gradient accumulation of 4 steps to maintain training stability.</a:t>
             </a:r>
           </a:p>
         </p:txBody>
@@ -5232,7 +5810,7 @@
         <p:spPr>
           <a:xfrm>
             <a:off x="6339535" y="1920240"/>
-            <a:ext cx="5303520" cy="4206240"/>
+            <a:ext cx="5303520" cy="4114800"/>
           </a:xfrm>
           <a:prstGeom prst="rect">
             <a:avLst/>
@@ -5321,8 +5899,8 @@
         </p:nvSpPr>
         <p:spPr>
           <a:xfrm>
-            <a:off x="6613855" y="2103120"/>
-            <a:ext cx="4754880" cy="731520"/>
+            <a:off x="6613855" y="2194560"/>
+            <a:ext cx="4754880" cy="3566160"/>
           </a:xfrm>
           <a:prstGeom prst="rect">
             <a:avLst/>
@@ -5330,13 +5908,340 @@
           <a:noFill/>
         </p:spPr>
         <p:txBody>
+          <a:bodyPr wrap="square">
+            <a:spAutoFit/>
+          </a:bodyPr>
+          <a:lstStyle/>
+          <a:p>
+            <a:pPr>
+              <a:spcAft>
+                <a:spcPts val="1200"/>
+              </a:spcAft>
+              <a:defRPr sz="2000" b="1">
+                <a:solidFill>
+                  <a:srgbClr val="0F172A"/>
+                </a:solidFill>
+                <a:latin typeface="Calibri"/>
+              </a:defRPr>
+            </a:pPr>
+            <a:r>
+              <a:t>2. Path Resolution &amp; Fallback Crashes</a:t>
+            </a:r>
+          </a:p>
+          <a:p>
+            <a:pPr>
+              <a:spcBef>
+                <a:spcPts val="600"/>
+              </a:spcBef>
+              <a:defRPr sz="1100">
+                <a:solidFill>
+                  <a:srgbClr val="475569"/>
+                </a:solidFill>
+                <a:latin typeface="Calibri"/>
+              </a:defRPr>
+            </a:pPr>
+            <a:r>
+              <a:t>• Challenge: If the final-adapter weight directory was absent, the script attempted to download it from Hugging Face, crashing with a HFValidationError.</a:t>
+            </a:r>
+          </a:p>
+          <a:p>
+            <a:pPr>
+              <a:spcBef>
+                <a:spcPts val="600"/>
+              </a:spcBef>
+              <a:defRPr sz="1100">
+                <a:solidFill>
+                  <a:srgbClr val="475569"/>
+                </a:solidFill>
+                <a:latin typeface="Calibri"/>
+              </a:defRPr>
+            </a:pPr>
+            <a:r>
+              <a:t>• Solution: Refactored paths in both app.py and inference.py to verify local folder existence recursively.</a:t>
+            </a:r>
+          </a:p>
+          <a:p>
+            <a:pPr>
+              <a:spcBef>
+                <a:spcPts val="600"/>
+              </a:spcBef>
+              <a:defRPr sz="1100">
+                <a:solidFill>
+                  <a:srgbClr val="475569"/>
+                </a:solidFill>
+                <a:latin typeface="Calibri"/>
+              </a:defRPr>
+            </a:pPr>
+            <a:r>
+              <a:t>• Solution: Implemented fallback logic to load intermediate checkpoints (like checkpoint-25/) if the final adapter is missing.</a:t>
+            </a:r>
+          </a:p>
+          <a:p>
+            <a:pPr>
+              <a:spcBef>
+                <a:spcPts val="600"/>
+              </a:spcBef>
+              <a:defRPr sz="1100">
+                <a:solidFill>
+                  <a:srgbClr val="475569"/>
+                </a:solidFill>
+                <a:latin typeface="Calibri"/>
+              </a:defRPr>
+            </a:pPr>
+            <a:r>
+              <a:t>• Solution: Added safety fallback to the base TinyLlama model, ensuring the app starts gracefully even without any adapters.</a:t>
+            </a:r>
+          </a:p>
+        </p:txBody>
+      </p:sp>
+    </p:spTree>
+  </p:cSld>
+  <p:clrMapOvr>
+    <a:masterClrMapping/>
+  </p:clrMapOvr>
+</p:sld>
+</file>
+
+<file path=ppt/slides/slide6.xml><?xml version="1.0" encoding="utf-8"?>
+<p:sld xmlns:a="http://schemas.openxmlformats.org/drawingml/2006/main" xmlns:p="http://schemas.openxmlformats.org/presentationml/2006/main" xmlns:r="http://schemas.openxmlformats.org/officeDocument/2006/relationships">
+  <p:cSld>
+    <p:bg>
+      <p:bgPr>
+        <a:solidFill>
+          <a:srgbClr val="F8FAFC"/>
+        </a:solidFill>
+        <a:effectLst/>
+      </p:bgPr>
+    </p:bg>
+    <p:spTree>
+      <p:nvGrpSpPr>
+        <p:cNvPr id="1" name=""/>
+        <p:cNvGrpSpPr/>
+        <p:nvPr/>
+      </p:nvGrpSpPr>
+      <p:grpSpPr/>
+      <p:sp>
+        <p:nvSpPr>
+          <p:cNvPr id="2" name="TextBox 1"/>
+          <p:cNvSpPr txBox="1"/>
+          <p:nvPr/>
+        </p:nvSpPr>
+        <p:spPr>
+          <a:xfrm>
+            <a:off x="548640" y="365760"/>
+            <a:ext cx="11094415" cy="274320"/>
+          </a:xfrm>
+          <a:prstGeom prst="rect">
+            <a:avLst/>
+          </a:prstGeom>
+          <a:noFill/>
+        </p:spPr>
+        <p:txBody>
+          <a:bodyPr wrap="square" lIns="0" rIns="0" tIns="0" bIns="0">
+            <a:spAutoFit/>
+          </a:bodyPr>
+          <a:lstStyle/>
+          <a:p>
+            <a:pPr>
+              <a:defRPr sz="1000" b="1">
+                <a:solidFill>
+                  <a:srgbClr val="C5A059"/>
+                </a:solidFill>
+                <a:latin typeface="Calibri"/>
+              </a:defRPr>
+            </a:pPr>
+            <a:r>
+              <a:t>RESULTS &amp; CONCLUSION</a:t>
+            </a:r>
+          </a:p>
+        </p:txBody>
+      </p:sp>
+      <p:sp>
+        <p:nvSpPr>
+          <p:cNvPr id="3" name="TextBox 2"/>
+          <p:cNvSpPr txBox="1"/>
+          <p:nvPr/>
+        </p:nvSpPr>
+        <p:spPr>
+          <a:xfrm>
+            <a:off x="548640" y="640080"/>
+            <a:ext cx="11094415" cy="731520"/>
+          </a:xfrm>
+          <a:prstGeom prst="rect">
+            <a:avLst/>
+          </a:prstGeom>
+          <a:noFill/>
+        </p:spPr>
+        <p:txBody>
+          <a:bodyPr wrap="square" lIns="0" rIns="0" tIns="0" bIns="0">
+            <a:spAutoFit/>
+          </a:bodyPr>
+          <a:lstStyle/>
+          <a:p>
+            <a:pPr>
+              <a:defRPr sz="3200" b="1">
+                <a:solidFill>
+                  <a:srgbClr val="0F172A"/>
+                </a:solidFill>
+                <a:latin typeface="Calibri"/>
+              </a:defRPr>
+            </a:pPr>
+            <a:r>
+              <a:t>Empirical Results &amp; Conclusion</a:t>
+            </a:r>
+          </a:p>
+        </p:txBody>
+      </p:sp>
+      <p:sp>
+        <p:nvSpPr>
+          <p:cNvPr id="4" name="TextBox 3"/>
+          <p:cNvSpPr txBox="1"/>
+          <p:nvPr/>
+        </p:nvSpPr>
+        <p:spPr>
+          <a:xfrm>
+            <a:off x="548640" y="1371600"/>
+            <a:ext cx="11094415" cy="365760"/>
+          </a:xfrm>
+          <a:prstGeom prst="rect">
+            <a:avLst/>
+          </a:prstGeom>
+          <a:noFill/>
+        </p:spPr>
+        <p:txBody>
           <a:bodyPr wrap="none">
             <a:spAutoFit/>
           </a:bodyPr>
           <a:lstStyle/>
           <a:p>
             <a:pPr>
-              <a:defRPr sz="2000" b="1">
+              <a:defRPr sz="1500">
+                <a:solidFill>
+                  <a:srgbClr val="475569"/>
+                </a:solidFill>
+                <a:latin typeface="Calibri"/>
+              </a:defRPr>
+            </a:pPr>
+            <a:r>
+              <a:t>Analyzing model convergence metrics and summarizing project takeaways.</a:t>
+            </a:r>
+          </a:p>
+        </p:txBody>
+      </p:sp>
+      <p:sp>
+        <p:nvSpPr>
+          <p:cNvPr id="5" name="Rectangle 4"/>
+          <p:cNvSpPr/>
+          <p:nvPr/>
+        </p:nvSpPr>
+        <p:spPr>
+          <a:xfrm>
+            <a:off x="548640" y="1920240"/>
+            <a:ext cx="5303520" cy="4114800"/>
+          </a:xfrm>
+          <a:prstGeom prst="rect">
+            <a:avLst/>
+          </a:prstGeom>
+          <a:solidFill>
+            <a:srgbClr val="FFFFFF"/>
+          </a:solidFill>
+          <a:ln w="12700">
+            <a:solidFill>
+              <a:srgbClr val="E2E8F0"/>
+            </a:solidFill>
+          </a:ln>
+        </p:spPr>
+        <p:style>
+          <a:lnRef idx="1">
+            <a:schemeClr val="accent1"/>
+          </a:lnRef>
+          <a:fillRef idx="3">
+            <a:schemeClr val="accent1"/>
+          </a:fillRef>
+          <a:effectRef idx="2">
+            <a:schemeClr val="accent1"/>
+          </a:effectRef>
+          <a:fontRef idx="minor">
+            <a:schemeClr val="lt1"/>
+          </a:fontRef>
+        </p:style>
+        <p:txBody>
+          <a:bodyPr rtlCol="0" anchor="ctr"/>
+          <a:lstStyle/>
+          <a:p>
+            <a:pPr algn="ctr"/>
+          </a:p>
+        </p:txBody>
+      </p:sp>
+      <p:sp>
+        <p:nvSpPr>
+          <p:cNvPr id="6" name="Rectangle 5"/>
+          <p:cNvSpPr/>
+          <p:nvPr/>
+        </p:nvSpPr>
+        <p:spPr>
+          <a:xfrm>
+            <a:off x="548640" y="1920240"/>
+            <a:ext cx="5303520" cy="91440"/>
+          </a:xfrm>
+          <a:prstGeom prst="rect">
+            <a:avLst/>
+          </a:prstGeom>
+          <a:solidFill>
+            <a:srgbClr val="475569"/>
+          </a:solidFill>
+          <a:ln>
+            <a:solidFill>
+              <a:srgbClr val="475569"/>
+            </a:solidFill>
+          </a:ln>
+        </p:spPr>
+        <p:style>
+          <a:lnRef idx="1">
+            <a:schemeClr val="accent1"/>
+          </a:lnRef>
+          <a:fillRef idx="3">
+            <a:schemeClr val="accent1"/>
+          </a:fillRef>
+          <a:effectRef idx="2">
+            <a:schemeClr val="accent1"/>
+          </a:effectRef>
+          <a:fontRef idx="minor">
+            <a:schemeClr val="lt1"/>
+          </a:fontRef>
+        </p:style>
+        <p:txBody>
+          <a:bodyPr rtlCol="0" anchor="ctr"/>
+          <a:lstStyle/>
+          <a:p>
+            <a:pPr algn="ctr"/>
+          </a:p>
+        </p:txBody>
+      </p:sp>
+      <p:sp>
+        <p:nvSpPr>
+          <p:cNvPr id="7" name="TextBox 6"/>
+          <p:cNvSpPr txBox="1"/>
+          <p:nvPr/>
+        </p:nvSpPr>
+        <p:spPr>
+          <a:xfrm>
+            <a:off x="822960" y="2103120"/>
+            <a:ext cx="4754880" cy="457200"/>
+          </a:xfrm>
+          <a:prstGeom prst="rect">
+            <a:avLst/>
+          </a:prstGeom>
+          <a:noFill/>
+        </p:spPr>
+        <p:txBody>
+          <a:bodyPr wrap="none">
+            <a:spAutoFit/>
+          </a:bodyPr>
+          <a:lstStyle/>
+          <a:p>
+            <a:pPr>
+              <a:defRPr sz="1800" b="1">
                 <a:solidFill>
                   <a:srgbClr val="0F172A"/>
                 </a:solidFill>
@@ -5344,21 +6249,21 @@
               </a:defRPr>
             </a:pPr>
             <a:r>
-              <a:t>Empirical Training Loss Metrics</a:t>
+              <a:t>Loss Convergence Table</a:t>
             </a:r>
           </a:p>
         </p:txBody>
       </p:sp>
       <p:graphicFrame>
         <p:nvGraphicFramePr>
-          <p:cNvPr id="11" name="Table 10"/>
+          <p:cNvPr id="8" name="Table 7"/>
           <p:cNvGraphicFramePr>
             <a:graphicFrameLocks noGrp="1"/>
           </p:cNvGraphicFramePr>
           <p:nvPr/>
         </p:nvGraphicFramePr>
         <p:xfrm>
-          <a:off x="6613855" y="2697480"/>
+          <a:off x="822960" y="2651760"/>
           <a:ext cx="4754880" cy="2926080"/>
         </p:xfrm>
         <a:graphic>
@@ -5368,10 +6273,9 @@
                 <a:tableStyleId>{5C22544A-7EE6-4342-B048-85BDC9FD1C3A}</a:tableStyleId>
               </a:tblPr>
               <a:tblGrid>
-                <a:gridCol w="1005840"/>
-                <a:gridCol w="1097280"/>
-                <a:gridCol w="1280160"/>
-                <a:gridCol w="1371600"/>
+                <a:gridCol w="1463040"/>
+                <a:gridCol w="1645920"/>
+                <a:gridCol w="1645920"/>
               </a:tblGrid>
               <a:tr h="487680">
                 <a:tc>
@@ -5446,30 +6350,6 @@
                     </a:solidFill>
                   </a:tcPr>
                 </a:tc>
-                <a:tc>
-                  <a:txBody>
-                    <a:bodyPr/>
-                    <a:lstStyle/>
-                    <a:p>
-                      <a:pPr algn="ctr">
-                        <a:defRPr sz="1100" b="1">
-                          <a:solidFill>
-                            <a:srgbClr val="FFFFFF"/>
-                          </a:solidFill>
-                          <a:latin typeface="Calibri"/>
-                        </a:defRPr>
-                      </a:pPr>
-                      <a:r>
-                        <a:t>Learning Rate</a:t>
-                      </a:r>
-                    </a:p>
-                  </a:txBody>
-                  <a:tcPr>
-                    <a:solidFill>
-                      <a:srgbClr val="0F172A"/>
-                    </a:solidFill>
-                  </a:tcPr>
-                </a:tc>
               </a:tr>
               <a:tr h="487680">
                 <a:tc>
@@ -5478,7 +6358,7 @@
                     <a:lstStyle/>
                     <a:p>
                       <a:pPr algn="ctr">
-                        <a:defRPr sz="1050">
+                        <a:defRPr sz="1100">
                           <a:solidFill>
                             <a:srgbClr val="475569"/>
                           </a:solidFill>
@@ -5502,7 +6382,7 @@
                     <a:lstStyle/>
                     <a:p>
                       <a:pPr algn="ctr">
-                        <a:defRPr sz="1050">
+                        <a:defRPr sz="1100">
                           <a:solidFill>
                             <a:srgbClr val="475569"/>
                           </a:solidFill>
@@ -5526,7 +6406,7 @@
                     <a:lstStyle/>
                     <a:p>
                       <a:pPr algn="ctr">
-                        <a:defRPr sz="1050" b="1">
+                        <a:defRPr sz="1100" b="1">
                           <a:solidFill>
                             <a:srgbClr val="0F172A"/>
                           </a:solidFill>
@@ -5544,30 +6424,6 @@
                     </a:solidFill>
                   </a:tcPr>
                 </a:tc>
-                <a:tc>
-                  <a:txBody>
-                    <a:bodyPr/>
-                    <a:lstStyle/>
-                    <a:p>
-                      <a:pPr algn="ctr">
-                        <a:defRPr sz="1050">
-                          <a:solidFill>
-                            <a:srgbClr val="475569"/>
-                          </a:solidFill>
-                          <a:latin typeface="Calibri"/>
-                        </a:defRPr>
-                      </a:pPr>
-                      <a:r>
-                        <a:t>2.0e-4</a:t>
-                      </a:r>
-                    </a:p>
-                  </a:txBody>
-                  <a:tcPr>
-                    <a:solidFill>
-                      <a:srgbClr val="F1F5F9"/>
-                    </a:solidFill>
-                  </a:tcPr>
-                </a:tc>
               </a:tr>
               <a:tr h="487680">
                 <a:tc>
@@ -5576,7 +6432,7 @@
                     <a:lstStyle/>
                     <a:p>
                       <a:pPr algn="ctr">
-                        <a:defRPr sz="1050">
+                        <a:defRPr sz="1100">
                           <a:solidFill>
                             <a:srgbClr val="475569"/>
                           </a:solidFill>
@@ -5600,7 +6456,7 @@
                     <a:lstStyle/>
                     <a:p>
                       <a:pPr algn="ctr">
-                        <a:defRPr sz="1050">
+                        <a:defRPr sz="1100">
                           <a:solidFill>
                             <a:srgbClr val="475569"/>
                           </a:solidFill>
@@ -5624,7 +6480,7 @@
                     <a:lstStyle/>
                     <a:p>
                       <a:pPr algn="ctr">
-                        <a:defRPr sz="1050" b="1">
+                        <a:defRPr sz="1100" b="1">
                           <a:solidFill>
                             <a:srgbClr val="0F172A"/>
                           </a:solidFill>
@@ -5642,30 +6498,6 @@
                     </a:solidFill>
                   </a:tcPr>
                 </a:tc>
-                <a:tc>
-                  <a:txBody>
-                    <a:bodyPr/>
-                    <a:lstStyle/>
-                    <a:p>
-                      <a:pPr algn="ctr">
-                        <a:defRPr sz="1050">
-                          <a:solidFill>
-                            <a:srgbClr val="475569"/>
-                          </a:solidFill>
-                          <a:latin typeface="Calibri"/>
-                        </a:defRPr>
-                      </a:pPr>
-                      <a:r>
-                        <a:t>2.0e-4</a:t>
-                      </a:r>
-                    </a:p>
-                  </a:txBody>
-                  <a:tcPr>
-                    <a:solidFill>
-                      <a:srgbClr val="FFFFFF"/>
-                    </a:solidFill>
-                  </a:tcPr>
-                </a:tc>
               </a:tr>
               <a:tr h="487680">
                 <a:tc>
@@ -5674,7 +6506,7 @@
                     <a:lstStyle/>
                     <a:p>
                       <a:pPr algn="ctr">
-                        <a:defRPr sz="1050">
+                        <a:defRPr sz="1100">
                           <a:solidFill>
                             <a:srgbClr val="475569"/>
                           </a:solidFill>
@@ -5698,7 +6530,7 @@
                     <a:lstStyle/>
                     <a:p>
                       <a:pPr algn="ctr">
-                        <a:defRPr sz="1050">
+                        <a:defRPr sz="1100">
                           <a:solidFill>
                             <a:srgbClr val="475569"/>
                           </a:solidFill>
@@ -5722,7 +6554,7 @@
                     <a:lstStyle/>
                     <a:p>
                       <a:pPr algn="ctr">
-                        <a:defRPr sz="1050" b="1">
+                        <a:defRPr sz="1100" b="1">
                           <a:solidFill>
                             <a:srgbClr val="0F172A"/>
                           </a:solidFill>
@@ -5740,30 +6572,6 @@
                     </a:solidFill>
                   </a:tcPr>
                 </a:tc>
-                <a:tc>
-                  <a:txBody>
-                    <a:bodyPr/>
-                    <a:lstStyle/>
-                    <a:p>
-                      <a:pPr algn="ctr">
-                        <a:defRPr sz="1050">
-                          <a:solidFill>
-                            <a:srgbClr val="475569"/>
-                          </a:solidFill>
-                          <a:latin typeface="Calibri"/>
-                        </a:defRPr>
-                      </a:pPr>
-                      <a:r>
-                        <a:t>2.0e-4</a:t>
-                      </a:r>
-                    </a:p>
-                  </a:txBody>
-                  <a:tcPr>
-                    <a:solidFill>
-                      <a:srgbClr val="F1F5F9"/>
-                    </a:solidFill>
-                  </a:tcPr>
-                </a:tc>
               </a:tr>
               <a:tr h="487680">
                 <a:tc>
@@ -5772,7 +6580,7 @@
                     <a:lstStyle/>
                     <a:p>
                       <a:pPr algn="ctr">
-                        <a:defRPr sz="1050">
+                        <a:defRPr sz="1100">
                           <a:solidFill>
                             <a:srgbClr val="475569"/>
                           </a:solidFill>
@@ -5796,7 +6604,7 @@
                     <a:lstStyle/>
                     <a:p>
                       <a:pPr algn="ctr">
-                        <a:defRPr sz="1050">
+                        <a:defRPr sz="1100">
                           <a:solidFill>
                             <a:srgbClr val="475569"/>
                           </a:solidFill>
@@ -5820,7 +6628,7 @@
                     <a:lstStyle/>
                     <a:p>
                       <a:pPr algn="ctr">
-                        <a:defRPr sz="1050" b="1">
+                        <a:defRPr sz="1100" b="1">
                           <a:solidFill>
                             <a:srgbClr val="0F172A"/>
                           </a:solidFill>
@@ -5838,30 +6646,6 @@
                     </a:solidFill>
                   </a:tcPr>
                 </a:tc>
-                <a:tc>
-                  <a:txBody>
-                    <a:bodyPr/>
-                    <a:lstStyle/>
-                    <a:p>
-                      <a:pPr algn="ctr">
-                        <a:defRPr sz="1050">
-                          <a:solidFill>
-                            <a:srgbClr val="475569"/>
-                          </a:solidFill>
-                          <a:latin typeface="Calibri"/>
-                        </a:defRPr>
-                      </a:pPr>
-                      <a:r>
-                        <a:t>2.0e-4</a:t>
-                      </a:r>
-                    </a:p>
-                  </a:txBody>
-                  <a:tcPr>
-                    <a:solidFill>
-                      <a:srgbClr val="FFFFFF"/>
-                    </a:solidFill>
-                  </a:tcPr>
-                </a:tc>
               </a:tr>
               <a:tr h="487680">
                 <a:tc>
@@ -5870,7 +6654,7 @@
                     <a:lstStyle/>
                     <a:p>
                       <a:pPr algn="ctr">
-                        <a:defRPr sz="1050">
+                        <a:defRPr sz="1100">
                           <a:solidFill>
                             <a:srgbClr val="475569"/>
                           </a:solidFill>
@@ -5894,7 +6678,7 @@
                     <a:lstStyle/>
                     <a:p>
                       <a:pPr algn="ctr">
-                        <a:defRPr sz="1050">
+                        <a:defRPr sz="1100">
                           <a:solidFill>
                             <a:srgbClr val="475569"/>
                           </a:solidFill>
@@ -5918,7 +6702,7 @@
                     <a:lstStyle/>
                     <a:p>
                       <a:pPr algn="ctr">
-                        <a:defRPr sz="1050" b="1">
+                        <a:defRPr sz="1100" b="1">
                           <a:solidFill>
                             <a:srgbClr val="0F172A"/>
                           </a:solidFill>
@@ -5936,35 +6720,204 @@
                     </a:solidFill>
                   </a:tcPr>
                 </a:tc>
-                <a:tc>
-                  <a:txBody>
-                    <a:bodyPr/>
-                    <a:lstStyle/>
-                    <a:p>
-                      <a:pPr algn="ctr">
-                        <a:defRPr sz="1050">
-                          <a:solidFill>
-                            <a:srgbClr val="475569"/>
-                          </a:solidFill>
-                          <a:latin typeface="Calibri"/>
-                        </a:defRPr>
-                      </a:pPr>
-                      <a:r>
-                        <a:t>2.0e-4</a:t>
-                      </a:r>
-                    </a:p>
-                  </a:txBody>
-                  <a:tcPr>
-                    <a:solidFill>
-                      <a:srgbClr val="F1F5F9"/>
-                    </a:solidFill>
-                  </a:tcPr>
-                </a:tc>
               </a:tr>
             </a:tbl>
           </a:graphicData>
         </a:graphic>
       </p:graphicFrame>
+      <p:sp>
+        <p:nvSpPr>
+          <p:cNvPr id="9" name="Rectangle 8"/>
+          <p:cNvSpPr/>
+          <p:nvPr/>
+        </p:nvSpPr>
+        <p:spPr>
+          <a:xfrm>
+            <a:off x="6339535" y="1920240"/>
+            <a:ext cx="5303520" cy="4114800"/>
+          </a:xfrm>
+          <a:prstGeom prst="rect">
+            <a:avLst/>
+          </a:prstGeom>
+          <a:solidFill>
+            <a:srgbClr val="FFFFFF"/>
+          </a:solidFill>
+          <a:ln w="19050">
+            <a:solidFill>
+              <a:srgbClr val="E2E8F0"/>
+            </a:solidFill>
+          </a:ln>
+        </p:spPr>
+        <p:style>
+          <a:lnRef idx="1">
+            <a:schemeClr val="accent1"/>
+          </a:lnRef>
+          <a:fillRef idx="3">
+            <a:schemeClr val="accent1"/>
+          </a:fillRef>
+          <a:effectRef idx="2">
+            <a:schemeClr val="accent1"/>
+          </a:effectRef>
+          <a:fontRef idx="minor">
+            <a:schemeClr val="lt1"/>
+          </a:fontRef>
+        </p:style>
+        <p:txBody>
+          <a:bodyPr rtlCol="0" anchor="ctr"/>
+          <a:lstStyle/>
+          <a:p>
+            <a:pPr algn="ctr"/>
+          </a:p>
+        </p:txBody>
+      </p:sp>
+      <p:sp>
+        <p:nvSpPr>
+          <p:cNvPr id="10" name="Rectangle 9"/>
+          <p:cNvSpPr/>
+          <p:nvPr/>
+        </p:nvSpPr>
+        <p:spPr>
+          <a:xfrm>
+            <a:off x="6339535" y="1920240"/>
+            <a:ext cx="5303520" cy="91440"/>
+          </a:xfrm>
+          <a:prstGeom prst="rect">
+            <a:avLst/>
+          </a:prstGeom>
+          <a:solidFill>
+            <a:srgbClr val="C5A059"/>
+          </a:solidFill>
+          <a:ln>
+            <a:solidFill>
+              <a:srgbClr val="C5A059"/>
+            </a:solidFill>
+          </a:ln>
+        </p:spPr>
+        <p:style>
+          <a:lnRef idx="1">
+            <a:schemeClr val="accent1"/>
+          </a:lnRef>
+          <a:fillRef idx="3">
+            <a:schemeClr val="accent1"/>
+          </a:fillRef>
+          <a:effectRef idx="2">
+            <a:schemeClr val="accent1"/>
+          </a:effectRef>
+          <a:fontRef idx="minor">
+            <a:schemeClr val="lt1"/>
+          </a:fontRef>
+        </p:style>
+        <p:txBody>
+          <a:bodyPr rtlCol="0" anchor="ctr"/>
+          <a:lstStyle/>
+          <a:p>
+            <a:pPr algn="ctr"/>
+          </a:p>
+        </p:txBody>
+      </p:sp>
+      <p:sp>
+        <p:nvSpPr>
+          <p:cNvPr id="11" name="TextBox 10"/>
+          <p:cNvSpPr txBox="1"/>
+          <p:nvPr/>
+        </p:nvSpPr>
+        <p:spPr>
+          <a:xfrm>
+            <a:off x="6613855" y="2194560"/>
+            <a:ext cx="4754880" cy="3566160"/>
+          </a:xfrm>
+          <a:prstGeom prst="rect">
+            <a:avLst/>
+          </a:prstGeom>
+          <a:noFill/>
+        </p:spPr>
+        <p:txBody>
+          <a:bodyPr wrap="square">
+            <a:spAutoFit/>
+          </a:bodyPr>
+          <a:lstStyle/>
+          <a:p>
+            <a:pPr>
+              <a:spcAft>
+                <a:spcPts val="1200"/>
+              </a:spcAft>
+              <a:defRPr sz="2000" b="1">
+                <a:solidFill>
+                  <a:srgbClr val="0F172A"/>
+                </a:solidFill>
+                <a:latin typeface="Calibri"/>
+              </a:defRPr>
+            </a:pPr>
+            <a:r>
+              <a:t>Key Project Takeaways</a:t>
+            </a:r>
+          </a:p>
+          <a:p>
+            <a:pPr>
+              <a:spcBef>
+                <a:spcPts val="600"/>
+              </a:spcBef>
+              <a:defRPr sz="1100">
+                <a:solidFill>
+                  <a:srgbClr val="475569"/>
+                </a:solidFill>
+                <a:latin typeface="Calibri"/>
+              </a:defRPr>
+            </a:pPr>
+            <a:r>
+              <a:t>• Feasibility Proven: Fine-tuning a 1.1B parameter model on a standard CPU is completely viable with LoRA adapters.</a:t>
+            </a:r>
+          </a:p>
+          <a:p>
+            <a:pPr>
+              <a:spcBef>
+                <a:spcPts val="600"/>
+              </a:spcBef>
+              <a:defRPr sz="1100">
+                <a:solidFill>
+                  <a:srgbClr val="475569"/>
+                </a:solidFill>
+                <a:latin typeface="Calibri"/>
+              </a:defRPr>
+            </a:pPr>
+            <a:r>
+              <a:t>• Loss Convergence: Loss consistently decreased from 1.90 to 1.43, indicating the model successfully learned specific instruction structures.</a:t>
+            </a:r>
+          </a:p>
+          <a:p>
+            <a:pPr>
+              <a:spcBef>
+                <a:spcPts val="600"/>
+              </a:spcBef>
+              <a:defRPr sz="1100">
+                <a:solidFill>
+                  <a:srgbClr val="475569"/>
+                </a:solidFill>
+                <a:latin typeface="Calibri"/>
+              </a:defRPr>
+            </a:pPr>
+            <a:r>
+              <a:t>• Zero Cloud Cost: Avoided expensive cloud GPU endpoints while maintaining a low disk space overhead (~4.5MB adapters).</a:t>
+            </a:r>
+          </a:p>
+          <a:p>
+            <a:pPr>
+              <a:spcBef>
+                <a:spcPts val="600"/>
+              </a:spcBef>
+              <a:defRPr sz="1100">
+                <a:solidFill>
+                  <a:srgbClr val="475569"/>
+                </a:solidFill>
+                <a:latin typeface="Calibri"/>
+              </a:defRPr>
+            </a:pPr>
+            <a:r>
+              <a:t>• Offline Ready: Achieved private local execution with robust fallbacks, suitable for remote classrooms.</a:t>
+            </a:r>
+          </a:p>
+        </p:txBody>
+      </p:sp>
     </p:spTree>
   </p:cSld>
   <p:clrMapOvr>
@@ -5973,7 +6926,720 @@
 </p:sld>
 </file>
 
-<file path=ppt/slides/slide5.xml><?xml version="1.0" encoding="utf-8"?>
+<file path=ppt/slides/slide7.xml><?xml version="1.0" encoding="utf-8"?>
+<p:sld xmlns:a="http://schemas.openxmlformats.org/drawingml/2006/main" xmlns:p="http://schemas.openxmlformats.org/presentationml/2006/main" xmlns:r="http://schemas.openxmlformats.org/officeDocument/2006/relationships">
+  <p:cSld>
+    <p:bg>
+      <p:bgPr>
+        <a:solidFill>
+          <a:srgbClr val="F8FAFC"/>
+        </a:solidFill>
+        <a:effectLst/>
+      </p:bgPr>
+    </p:bg>
+    <p:spTree>
+      <p:nvGrpSpPr>
+        <p:cNvPr id="1" name=""/>
+        <p:cNvGrpSpPr/>
+        <p:nvPr/>
+      </p:nvGrpSpPr>
+      <p:grpSpPr/>
+      <p:sp>
+        <p:nvSpPr>
+          <p:cNvPr id="2" name="TextBox 1"/>
+          <p:cNvSpPr txBox="1"/>
+          <p:nvPr/>
+        </p:nvSpPr>
+        <p:spPr>
+          <a:xfrm>
+            <a:off x="548640" y="365760"/>
+            <a:ext cx="11094415" cy="274320"/>
+          </a:xfrm>
+          <a:prstGeom prst="rect">
+            <a:avLst/>
+          </a:prstGeom>
+          <a:noFill/>
+        </p:spPr>
+        <p:txBody>
+          <a:bodyPr wrap="square" lIns="0" rIns="0" tIns="0" bIns="0">
+            <a:spAutoFit/>
+          </a:bodyPr>
+          <a:lstStyle/>
+          <a:p>
+            <a:pPr>
+              <a:defRPr sz="1000" b="1">
+                <a:solidFill>
+                  <a:srgbClr val="C5A059"/>
+                </a:solidFill>
+                <a:latin typeface="Calibri"/>
+              </a:defRPr>
+            </a:pPr>
+            <a:r>
+              <a:t>FUTURE HORIZONS</a:t>
+            </a:r>
+          </a:p>
+        </p:txBody>
+      </p:sp>
+      <p:sp>
+        <p:nvSpPr>
+          <p:cNvPr id="3" name="TextBox 2"/>
+          <p:cNvSpPr txBox="1"/>
+          <p:nvPr/>
+        </p:nvSpPr>
+        <p:spPr>
+          <a:xfrm>
+            <a:off x="548640" y="640080"/>
+            <a:ext cx="11094415" cy="731520"/>
+          </a:xfrm>
+          <a:prstGeom prst="rect">
+            <a:avLst/>
+          </a:prstGeom>
+          <a:noFill/>
+        </p:spPr>
+        <p:txBody>
+          <a:bodyPr wrap="square" lIns="0" rIns="0" tIns="0" bIns="0">
+            <a:spAutoFit/>
+          </a:bodyPr>
+          <a:lstStyle/>
+          <a:p>
+            <a:pPr>
+              <a:defRPr sz="3200" b="1">
+                <a:solidFill>
+                  <a:srgbClr val="0F172A"/>
+                </a:solidFill>
+                <a:latin typeface="Calibri"/>
+              </a:defRPr>
+            </a:pPr>
+            <a:r>
+              <a:t>Future Directions</a:t>
+            </a:r>
+          </a:p>
+        </p:txBody>
+      </p:sp>
+      <p:sp>
+        <p:nvSpPr>
+          <p:cNvPr id="4" name="TextBox 3"/>
+          <p:cNvSpPr txBox="1"/>
+          <p:nvPr/>
+        </p:nvSpPr>
+        <p:spPr>
+          <a:xfrm>
+            <a:off x="548640" y="1371600"/>
+            <a:ext cx="11094415" cy="365760"/>
+          </a:xfrm>
+          <a:prstGeom prst="rect">
+            <a:avLst/>
+          </a:prstGeom>
+          <a:noFill/>
+        </p:spPr>
+        <p:txBody>
+          <a:bodyPr wrap="none">
+            <a:spAutoFit/>
+          </a:bodyPr>
+          <a:lstStyle/>
+          <a:p>
+            <a:pPr>
+              <a:defRPr sz="1500">
+                <a:solidFill>
+                  <a:srgbClr val="475569"/>
+                </a:solidFill>
+                <a:latin typeface="Calibri"/>
+              </a:defRPr>
+            </a:pPr>
+            <a:r>
+              <a:t>Proposed research expansions to scale capabilities and models.</a:t>
+            </a:r>
+          </a:p>
+        </p:txBody>
+      </p:sp>
+      <p:sp>
+        <p:nvSpPr>
+          <p:cNvPr id="5" name="Rounded Rectangle 4"/>
+          <p:cNvSpPr/>
+          <p:nvPr/>
+        </p:nvSpPr>
+        <p:spPr>
+          <a:xfrm>
+            <a:off x="548640" y="1920240"/>
+            <a:ext cx="3474720" cy="3931920"/>
+          </a:xfrm>
+          <a:prstGeom prst="roundRect">
+            <a:avLst/>
+          </a:prstGeom>
+          <a:solidFill>
+            <a:srgbClr val="FFFFFF"/>
+          </a:solidFill>
+          <a:ln w="19050">
+            <a:solidFill>
+              <a:srgbClr val="E2E8F0"/>
+            </a:solidFill>
+          </a:ln>
+        </p:spPr>
+        <p:style>
+          <a:lnRef idx="1">
+            <a:schemeClr val="accent1"/>
+          </a:lnRef>
+          <a:fillRef idx="3">
+            <a:schemeClr val="accent1"/>
+          </a:fillRef>
+          <a:effectRef idx="2">
+            <a:schemeClr val="accent1"/>
+          </a:effectRef>
+          <a:fontRef idx="minor">
+            <a:schemeClr val="lt1"/>
+          </a:fontRef>
+        </p:style>
+        <p:txBody>
+          <a:bodyPr rtlCol="0" anchor="ctr"/>
+          <a:lstStyle/>
+          <a:p>
+            <a:pPr algn="ctr"/>
+          </a:p>
+        </p:txBody>
+      </p:sp>
+      <p:sp>
+        <p:nvSpPr>
+          <p:cNvPr id="6" name="Rectangle 5"/>
+          <p:cNvSpPr/>
+          <p:nvPr/>
+        </p:nvSpPr>
+        <p:spPr>
+          <a:xfrm>
+            <a:off x="548640" y="1920240"/>
+            <a:ext cx="3474720" cy="109728"/>
+          </a:xfrm>
+          <a:prstGeom prst="rect">
+            <a:avLst/>
+          </a:prstGeom>
+          <a:solidFill>
+            <a:srgbClr val="C5A059"/>
+          </a:solidFill>
+          <a:ln>
+            <a:solidFill>
+              <a:srgbClr val="C5A059"/>
+            </a:solidFill>
+          </a:ln>
+        </p:spPr>
+        <p:style>
+          <a:lnRef idx="1">
+            <a:schemeClr val="accent1"/>
+          </a:lnRef>
+          <a:fillRef idx="3">
+            <a:schemeClr val="accent1"/>
+          </a:fillRef>
+          <a:effectRef idx="2">
+            <a:schemeClr val="accent1"/>
+          </a:effectRef>
+          <a:fontRef idx="minor">
+            <a:schemeClr val="lt1"/>
+          </a:fontRef>
+        </p:style>
+        <p:txBody>
+          <a:bodyPr rtlCol="0" anchor="ctr"/>
+          <a:lstStyle/>
+          <a:p>
+            <a:pPr algn="ctr"/>
+          </a:p>
+        </p:txBody>
+      </p:sp>
+      <p:sp>
+        <p:nvSpPr>
+          <p:cNvPr id="7" name="TextBox 6"/>
+          <p:cNvSpPr txBox="1"/>
+          <p:nvPr/>
+        </p:nvSpPr>
+        <p:spPr>
+          <a:xfrm>
+            <a:off x="731520" y="2194560"/>
+            <a:ext cx="3108960" cy="3474720"/>
+          </a:xfrm>
+          <a:prstGeom prst="rect">
+            <a:avLst/>
+          </a:prstGeom>
+          <a:noFill/>
+        </p:spPr>
+        <p:txBody>
+          <a:bodyPr wrap="square">
+            <a:spAutoFit/>
+          </a:bodyPr>
+          <a:lstStyle/>
+          <a:p>
+            <a:pPr>
+              <a:spcAft>
+                <a:spcPts val="200"/>
+              </a:spcAft>
+              <a:defRPr sz="2800" b="1">
+                <a:solidFill>
+                  <a:srgbClr val="C5A059"/>
+                </a:solidFill>
+                <a:latin typeface="Calibri"/>
+              </a:defRPr>
+            </a:pPr>
+            <a:r>
+              <a:t>01</a:t>
+            </a:r>
+          </a:p>
+          <a:p>
+            <a:pPr>
+              <a:spcAft>
+                <a:spcPts val="800"/>
+              </a:spcAft>
+              <a:defRPr sz="1800" b="1">
+                <a:solidFill>
+                  <a:srgbClr val="0F172A"/>
+                </a:solidFill>
+                <a:latin typeface="Calibri"/>
+              </a:defRPr>
+            </a:pPr>
+            <a:r>
+              <a:t>Scale Dataset &amp; Length</a:t>
+            </a:r>
+          </a:p>
+          <a:p>
+            <a:pPr>
+              <a:spcBef>
+                <a:spcPts val="400"/>
+              </a:spcBef>
+              <a:defRPr sz="1050">
+                <a:solidFill>
+                  <a:srgbClr val="475569"/>
+                </a:solidFill>
+                <a:latin typeface="Calibri"/>
+              </a:defRPr>
+            </a:pPr>
+            <a:r>
+              <a:t>• Increase the training subset from 1k to 10k+ instruction samples.</a:t>
+            </a:r>
+          </a:p>
+          <a:p>
+            <a:pPr>
+              <a:spcBef>
+                <a:spcPts val="400"/>
+              </a:spcBef>
+              <a:defRPr sz="1050">
+                <a:solidFill>
+                  <a:srgbClr val="475569"/>
+                </a:solidFill>
+                <a:latin typeface="Calibri"/>
+              </a:defRPr>
+            </a:pPr>
+            <a:r>
+              <a:t>• Extend maximum context length from 512 to 2048 tokens to support textbook-length chapters.</a:t>
+            </a:r>
+          </a:p>
+          <a:p>
+            <a:pPr>
+              <a:spcBef>
+                <a:spcPts val="400"/>
+              </a:spcBef>
+              <a:defRPr sz="1050">
+                <a:solidFill>
+                  <a:srgbClr val="475569"/>
+                </a:solidFill>
+                <a:latin typeface="Calibri"/>
+              </a:defRPr>
+            </a:pPr>
+            <a:r>
+              <a:t>• Include specialized subjects like STEM and Coding in dataset.</a:t>
+            </a:r>
+          </a:p>
+        </p:txBody>
+      </p:sp>
+      <p:sp>
+        <p:nvSpPr>
+          <p:cNvPr id="8" name="Rounded Rectangle 7"/>
+          <p:cNvSpPr/>
+          <p:nvPr/>
+        </p:nvSpPr>
+        <p:spPr>
+          <a:xfrm>
+            <a:off x="4352544" y="1920240"/>
+            <a:ext cx="3474720" cy="3931920"/>
+          </a:xfrm>
+          <a:prstGeom prst="roundRect">
+            <a:avLst/>
+          </a:prstGeom>
+          <a:solidFill>
+            <a:srgbClr val="FFFFFF"/>
+          </a:solidFill>
+          <a:ln w="19050">
+            <a:solidFill>
+              <a:srgbClr val="E2E8F0"/>
+            </a:solidFill>
+          </a:ln>
+        </p:spPr>
+        <p:style>
+          <a:lnRef idx="1">
+            <a:schemeClr val="accent1"/>
+          </a:lnRef>
+          <a:fillRef idx="3">
+            <a:schemeClr val="accent1"/>
+          </a:fillRef>
+          <a:effectRef idx="2">
+            <a:schemeClr val="accent1"/>
+          </a:effectRef>
+          <a:fontRef idx="minor">
+            <a:schemeClr val="lt1"/>
+          </a:fontRef>
+        </p:style>
+        <p:txBody>
+          <a:bodyPr rtlCol="0" anchor="ctr"/>
+          <a:lstStyle/>
+          <a:p>
+            <a:pPr algn="ctr"/>
+          </a:p>
+        </p:txBody>
+      </p:sp>
+      <p:sp>
+        <p:nvSpPr>
+          <p:cNvPr id="9" name="Rectangle 8"/>
+          <p:cNvSpPr/>
+          <p:nvPr/>
+        </p:nvSpPr>
+        <p:spPr>
+          <a:xfrm>
+            <a:off x="4352544" y="1920240"/>
+            <a:ext cx="3474720" cy="109728"/>
+          </a:xfrm>
+          <a:prstGeom prst="rect">
+            <a:avLst/>
+          </a:prstGeom>
+          <a:solidFill>
+            <a:srgbClr val="C5A059"/>
+          </a:solidFill>
+          <a:ln>
+            <a:solidFill>
+              <a:srgbClr val="C5A059"/>
+            </a:solidFill>
+          </a:ln>
+        </p:spPr>
+        <p:style>
+          <a:lnRef idx="1">
+            <a:schemeClr val="accent1"/>
+          </a:lnRef>
+          <a:fillRef idx="3">
+            <a:schemeClr val="accent1"/>
+          </a:fillRef>
+          <a:effectRef idx="2">
+            <a:schemeClr val="accent1"/>
+          </a:effectRef>
+          <a:fontRef idx="minor">
+            <a:schemeClr val="lt1"/>
+          </a:fontRef>
+        </p:style>
+        <p:txBody>
+          <a:bodyPr rtlCol="0" anchor="ctr"/>
+          <a:lstStyle/>
+          <a:p>
+            <a:pPr algn="ctr"/>
+          </a:p>
+        </p:txBody>
+      </p:sp>
+      <p:sp>
+        <p:nvSpPr>
+          <p:cNvPr id="10" name="TextBox 9"/>
+          <p:cNvSpPr txBox="1"/>
+          <p:nvPr/>
+        </p:nvSpPr>
+        <p:spPr>
+          <a:xfrm>
+            <a:off x="4535424" y="2194560"/>
+            <a:ext cx="3108960" cy="3474720"/>
+          </a:xfrm>
+          <a:prstGeom prst="rect">
+            <a:avLst/>
+          </a:prstGeom>
+          <a:noFill/>
+        </p:spPr>
+        <p:txBody>
+          <a:bodyPr wrap="square">
+            <a:spAutoFit/>
+          </a:bodyPr>
+          <a:lstStyle/>
+          <a:p>
+            <a:pPr>
+              <a:spcAft>
+                <a:spcPts val="200"/>
+              </a:spcAft>
+              <a:defRPr sz="2800" b="1">
+                <a:solidFill>
+                  <a:srgbClr val="C5A059"/>
+                </a:solidFill>
+                <a:latin typeface="Calibri"/>
+              </a:defRPr>
+            </a:pPr>
+            <a:r>
+              <a:t>02</a:t>
+            </a:r>
+          </a:p>
+          <a:p>
+            <a:pPr>
+              <a:spcAft>
+                <a:spcPts val="800"/>
+              </a:spcAft>
+              <a:defRPr sz="1800" b="1">
+                <a:solidFill>
+                  <a:srgbClr val="0F172A"/>
+                </a:solidFill>
+                <a:latin typeface="Calibri"/>
+              </a:defRPr>
+            </a:pPr>
+            <a:r>
+              <a:t>Quantized Larger Models</a:t>
+            </a:r>
+          </a:p>
+          <a:p>
+            <a:pPr>
+              <a:spcBef>
+                <a:spcPts val="400"/>
+              </a:spcBef>
+              <a:defRPr sz="1050">
+                <a:solidFill>
+                  <a:srgbClr val="475569"/>
+                </a:solidFill>
+                <a:latin typeface="Calibri"/>
+              </a:defRPr>
+            </a:pPr>
+            <a:r>
+              <a:t>• Fine-tune larger models (e.g. Qwen-2.5-7B or Gemma-2-9B).</a:t>
+            </a:r>
+          </a:p>
+          <a:p>
+            <a:pPr>
+              <a:spcBef>
+                <a:spcPts val="400"/>
+              </a:spcBef>
+              <a:defRPr sz="1050">
+                <a:solidFill>
+                  <a:srgbClr val="475569"/>
+                </a:solidFill>
+                <a:latin typeface="Calibri"/>
+              </a:defRPr>
+            </a:pPr>
+            <a:r>
+              <a:t>• Use llama.cpp or CPU bitsandbytes (4-bit/8-bit quantization) to run larger models under laptop constraints.</a:t>
+            </a:r>
+          </a:p>
+          <a:p>
+            <a:pPr>
+              <a:spcBef>
+                <a:spcPts val="400"/>
+              </a:spcBef>
+              <a:defRPr sz="1050">
+                <a:solidFill>
+                  <a:srgbClr val="475569"/>
+                </a:solidFill>
+                <a:latin typeface="Calibri"/>
+              </a:defRPr>
+            </a:pPr>
+            <a:r>
+              <a:t>• Benchmark trade-offs between speed and model parameter scale.</a:t>
+            </a:r>
+          </a:p>
+        </p:txBody>
+      </p:sp>
+      <p:sp>
+        <p:nvSpPr>
+          <p:cNvPr id="11" name="Rounded Rectangle 10"/>
+          <p:cNvSpPr/>
+          <p:nvPr/>
+        </p:nvSpPr>
+        <p:spPr>
+          <a:xfrm>
+            <a:off x="8156448" y="1920240"/>
+            <a:ext cx="3474720" cy="3931920"/>
+          </a:xfrm>
+          <a:prstGeom prst="roundRect">
+            <a:avLst/>
+          </a:prstGeom>
+          <a:solidFill>
+            <a:srgbClr val="FFFFFF"/>
+          </a:solidFill>
+          <a:ln w="19050">
+            <a:solidFill>
+              <a:srgbClr val="E2E8F0"/>
+            </a:solidFill>
+          </a:ln>
+        </p:spPr>
+        <p:style>
+          <a:lnRef idx="1">
+            <a:schemeClr val="accent1"/>
+          </a:lnRef>
+          <a:fillRef idx="3">
+            <a:schemeClr val="accent1"/>
+          </a:fillRef>
+          <a:effectRef idx="2">
+            <a:schemeClr val="accent1"/>
+          </a:effectRef>
+          <a:fontRef idx="minor">
+            <a:schemeClr val="lt1"/>
+          </a:fontRef>
+        </p:style>
+        <p:txBody>
+          <a:bodyPr rtlCol="0" anchor="ctr"/>
+          <a:lstStyle/>
+          <a:p>
+            <a:pPr algn="ctr"/>
+          </a:p>
+        </p:txBody>
+      </p:sp>
+      <p:sp>
+        <p:nvSpPr>
+          <p:cNvPr id="12" name="Rectangle 11"/>
+          <p:cNvSpPr/>
+          <p:nvPr/>
+        </p:nvSpPr>
+        <p:spPr>
+          <a:xfrm>
+            <a:off x="8156448" y="1920240"/>
+            <a:ext cx="3474720" cy="109728"/>
+          </a:xfrm>
+          <a:prstGeom prst="rect">
+            <a:avLst/>
+          </a:prstGeom>
+          <a:solidFill>
+            <a:srgbClr val="C5A059"/>
+          </a:solidFill>
+          <a:ln>
+            <a:solidFill>
+              <a:srgbClr val="C5A059"/>
+            </a:solidFill>
+          </a:ln>
+        </p:spPr>
+        <p:style>
+          <a:lnRef idx="1">
+            <a:schemeClr val="accent1"/>
+          </a:lnRef>
+          <a:fillRef idx="3">
+            <a:schemeClr val="accent1"/>
+          </a:fillRef>
+          <a:effectRef idx="2">
+            <a:schemeClr val="accent1"/>
+          </a:effectRef>
+          <a:fontRef idx="minor">
+            <a:schemeClr val="lt1"/>
+          </a:fontRef>
+        </p:style>
+        <p:txBody>
+          <a:bodyPr rtlCol="0" anchor="ctr"/>
+          <a:lstStyle/>
+          <a:p>
+            <a:pPr algn="ctr"/>
+          </a:p>
+        </p:txBody>
+      </p:sp>
+      <p:sp>
+        <p:nvSpPr>
+          <p:cNvPr id="13" name="TextBox 12"/>
+          <p:cNvSpPr txBox="1"/>
+          <p:nvPr/>
+        </p:nvSpPr>
+        <p:spPr>
+          <a:xfrm>
+            <a:off x="8339328" y="2194560"/>
+            <a:ext cx="3108960" cy="3474720"/>
+          </a:xfrm>
+          <a:prstGeom prst="rect">
+            <a:avLst/>
+          </a:prstGeom>
+          <a:noFill/>
+        </p:spPr>
+        <p:txBody>
+          <a:bodyPr wrap="square">
+            <a:spAutoFit/>
+          </a:bodyPr>
+          <a:lstStyle/>
+          <a:p>
+            <a:pPr>
+              <a:spcAft>
+                <a:spcPts val="200"/>
+              </a:spcAft>
+              <a:defRPr sz="2800" b="1">
+                <a:solidFill>
+                  <a:srgbClr val="C5A059"/>
+                </a:solidFill>
+                <a:latin typeface="Calibri"/>
+              </a:defRPr>
+            </a:pPr>
+            <a:r>
+              <a:t>03</a:t>
+            </a:r>
+          </a:p>
+          <a:p>
+            <a:pPr>
+              <a:spcAft>
+                <a:spcPts val="800"/>
+              </a:spcAft>
+              <a:defRPr sz="1800" b="1">
+                <a:solidFill>
+                  <a:srgbClr val="0F172A"/>
+                </a:solidFill>
+                <a:latin typeface="Calibri"/>
+              </a:defRPr>
+            </a:pPr>
+            <a:r>
+              <a:t>RAG Syllabus Integration</a:t>
+            </a:r>
+          </a:p>
+          <a:p>
+            <a:pPr>
+              <a:spcBef>
+                <a:spcPts val="400"/>
+              </a:spcBef>
+              <a:defRPr sz="1050">
+                <a:solidFill>
+                  <a:srgbClr val="475569"/>
+                </a:solidFill>
+                <a:latin typeface="Calibri"/>
+              </a:defRPr>
+            </a:pPr>
+            <a:r>
+              <a:t>• Incorporate Retrieval-Augmented Generation (RAG).</a:t>
+            </a:r>
+          </a:p>
+          <a:p>
+            <a:pPr>
+              <a:spcBef>
+                <a:spcPts val="400"/>
+              </a:spcBef>
+              <a:defRPr sz="1050">
+                <a:solidFill>
+                  <a:srgbClr val="475569"/>
+                </a:solidFill>
+                <a:latin typeface="Calibri"/>
+              </a:defRPr>
+            </a:pPr>
+            <a:r>
+              <a:t>• Allow teachers to upload classroom PDFs/syllabi locally.</a:t>
+            </a:r>
+          </a:p>
+          <a:p>
+            <a:pPr>
+              <a:spcBef>
+                <a:spcPts val="400"/>
+              </a:spcBef>
+              <a:defRPr sz="1050">
+                <a:solidFill>
+                  <a:srgbClr val="475569"/>
+                </a:solidFill>
+                <a:latin typeface="Calibri"/>
+              </a:defRPr>
+            </a:pPr>
+            <a:r>
+              <a:t>• Let the model ground its answers in the uploaded files, reducing generic hallucinations.</a:t>
+            </a:r>
+          </a:p>
+        </p:txBody>
+      </p:sp>
+    </p:spTree>
+  </p:cSld>
+  <p:clrMapOvr>
+    <a:masterClrMapping/>
+  </p:clrMapOvr>
+</p:sld>
+</file>
+
+<file path=ppt/slides/slide8.xml><?xml version="1.0" encoding="utf-8"?>
 <p:sld xmlns:a="http://schemas.openxmlformats.org/drawingml/2006/main" xmlns:p="http://schemas.openxmlformats.org/presentationml/2006/main" xmlns:r="http://schemas.openxmlformats.org/officeDocument/2006/relationships">
   <p:cSld>
     <p:bg>
@@ -6022,7 +7688,7 @@
               </a:defRPr>
             </a:pPr>
             <a:r>
-              <a:t>Results &amp; Classroom Deployment</a:t>
+              <a:t>GitHub Repository &amp; Setup Details</a:t>
             </a:r>
           </a:p>
         </p:txBody>
@@ -6058,7 +7724,7 @@
               </a:defRPr>
             </a:pPr>
             <a:r>
-              <a:t>Interactive local deployment with highly structured educational responses.</a:t>
+              <a:t>Open source code structure and execution guide.</a:t>
             </a:r>
           </a:p>
         </p:txBody>
@@ -6142,87 +7808,104 @@
               </a:defRPr>
             </a:pPr>
             <a:r>
-              <a:t>Streamlit Web App (app.py)</a:t>
+              <a:t>Repository Details &amp; Setup</a:t>
+            </a:r>
+          </a:p>
+          <a:p>
+            <a:pPr>
+              <a:defRPr sz="1100" b="1">
+                <a:solidFill>
+                  <a:srgbClr val="C5A059"/>
+                </a:solidFill>
+                <a:latin typeface="Calibri"/>
+              </a:defRPr>
+            </a:pPr>
+            <a:r>
+              <a:t>GitHub URL:</a:t>
+            </a:r>
+          </a:p>
+          <a:p>
+            <a:pPr>
+              <a:spcAft>
+                <a:spcPts val="800"/>
+              </a:spcAft>
+              <a:defRPr sz="1150">
+                <a:solidFill>
+                  <a:srgbClr val="FFFFFF"/>
+                </a:solidFill>
+                <a:latin typeface="Calibri"/>
+              </a:defRPr>
+            </a:pPr>
+            <a:r>
+              <a:t>https://github.com/deweshai-star/Instruction-Tuning-for-Educational-QA</a:t>
             </a:r>
           </a:p>
           <a:p>
             <a:pPr>
               <a:spcBef>
-                <a:spcPts val="600"/>
+                <a:spcPts val="400"/>
               </a:spcBef>
-              <a:defRPr sz="1150">
+              <a:defRPr sz="950">
                 <a:solidFill>
                   <a:srgbClr val="CBD5E1"/>
                 </a:solidFill>
-                <a:latin typeface="Calibri"/>
-              </a:defRPr>
-            </a:pPr>
-            <a:r>
-              <a:t>• Interactive Graphical User Interface (GUI) running in the web browser locally.</a:t>
+                <a:latin typeface="Courier New"/>
+              </a:defRPr>
+            </a:pPr>
+            <a:r>
+              <a:t>1. Clone Project:</a:t>
+            </a:r>
+            <a:br/>
+            <a:r>
+              <a:t>   git clone https://github.com/deweshai-star/Instruction-Tuning-for-Educational-QA.git</a:t>
             </a:r>
           </a:p>
           <a:p>
             <a:pPr>
               <a:spcBef>
-                <a:spcPts val="600"/>
+                <a:spcPts val="400"/>
               </a:spcBef>
-              <a:defRPr sz="1150">
+              <a:defRPr sz="950">
                 <a:solidFill>
                   <a:srgbClr val="CBD5E1"/>
                 </a:solidFill>
-                <a:latin typeface="Calibri"/>
-              </a:defRPr>
-            </a:pPr>
-            <a:r>
-              <a:t>• Proactively checks directory for fine-tuned LoRA adapters (final-adapter/ or checkpoint-25/).</a:t>
+                <a:latin typeface="Courier New"/>
+              </a:defRPr>
+            </a:pPr>
+            <a:r>
+              <a:t>2. Create Virtualenv &amp; Install:</a:t>
+            </a:r>
+            <a:br/>
+            <a:r>
+              <a:t>   python -m venv venv</a:t>
+            </a:r>
+            <a:br/>
+            <a:r>
+              <a:t>   .\venv\Scripts\activate</a:t>
+            </a:r>
+            <a:br/>
+            <a:r>
+              <a:t>   pip install -r requirements.txt</a:t>
             </a:r>
           </a:p>
           <a:p>
             <a:pPr>
               <a:spcBef>
-                <a:spcPts val="600"/>
+                <a:spcPts val="400"/>
               </a:spcBef>
-              <a:defRPr sz="1150">
+              <a:defRPr sz="950">
                 <a:solidFill>
                   <a:srgbClr val="CBD5E1"/>
                 </a:solidFill>
-                <a:latin typeface="Calibri"/>
-              </a:defRPr>
-            </a:pPr>
-            <a:r>
-              <a:t>• Graceful Fallback: Detects missing adapter directory and auto-loads base TinyLlama model.</a:t>
-            </a:r>
-          </a:p>
-          <a:p>
-            <a:pPr>
-              <a:spcBef>
-                <a:spcPts val="600"/>
-              </a:spcBef>
-              <a:defRPr sz="1150">
-                <a:solidFill>
-                  <a:srgbClr val="CBD5E1"/>
-                </a:solidFill>
-                <a:latin typeface="Calibri"/>
-              </a:defRPr>
-            </a:pPr>
-            <a:r>
-              <a:t>• Input interface: Custom prompt text area for entering instructions + context text box.</a:t>
-            </a:r>
-          </a:p>
-          <a:p>
-            <a:pPr>
-              <a:spcBef>
-                <a:spcPts val="600"/>
-              </a:spcBef>
-              <a:defRPr sz="1150">
-                <a:solidFill>
-                  <a:srgbClr val="CBD5E1"/>
-                </a:solidFill>
-                <a:latin typeface="Calibri"/>
-              </a:defRPr>
-            </a:pPr>
-            <a:r>
-              <a:t>• GPU-Free Generation: Executes tokenizer and PeftModel inference directly on CPU in under 45s.</a:t>
+                <a:latin typeface="Courier New"/>
+              </a:defRPr>
+            </a:pPr>
+            <a:r>
+              <a:t>3. Run Web App:</a:t>
+            </a:r>
+            <a:br/>
+            <a:r>
+              <a:t>   streamlit run app.py</a:t>
             </a:r>
           </a:p>
         </p:txBody>
@@ -6306,58 +7989,13 @@
               </a:defRPr>
             </a:pPr>
             <a:r>
-              <a:t>Sample Inference Performance</a:t>
+              <a:t>File Structure Specifications</a:t>
             </a:r>
           </a:p>
           <a:p>
             <a:pPr>
               <a:spcBef>
-                <a:spcPts val="400"/>
-              </a:spcBef>
-              <a:defRPr sz="1100" b="1">
-                <a:solidFill>
-                  <a:srgbClr val="C5A059"/>
-                </a:solidFill>
-                <a:latin typeface="Calibri"/>
-              </a:defRPr>
-            </a:pPr>
-            <a:r>
-              <a:t>Instruction (Question):</a:t>
-            </a:r>
-          </a:p>
-          <a:p>
-            <a:pPr>
-              <a:spcAft>
-                <a:spcPts val="800"/>
-              </a:spcAft>
-              <a:defRPr sz="1200" i="1">
-                <a:solidFill>
-                  <a:srgbClr val="0F172A"/>
-                </a:solidFill>
-                <a:latin typeface="Calibri"/>
-              </a:defRPr>
-            </a:pPr>
-            <a:r>
-              <a:t>“Explain the process of photosynthesis to a middle school student.”</a:t>
-            </a:r>
-          </a:p>
-          <a:p>
-            <a:pPr>
-              <a:defRPr sz="1100" b="1">
-                <a:solidFill>
-                  <a:srgbClr val="2563EB"/>
-                </a:solidFill>
-                <a:latin typeface="Calibri"/>
-              </a:defRPr>
-            </a:pPr>
-            <a:r>
-              <a:t>Fine-Tuned Response Output:</a:t>
-            </a:r>
-          </a:p>
-          <a:p>
-            <a:pPr>
-              <a:spcBef>
-                <a:spcPts val="200"/>
+                <a:spcPts val="500"/>
               </a:spcBef>
               <a:defRPr sz="1100">
                 <a:solidFill>
@@ -6367,12 +8005,87 @@
               </a:defRPr>
             </a:pPr>
             <a:r>
-              <a:t>“Photosynthesis is the process by which green plants and some other organisms use sunlight to synthesize foods from carbon dioxide and water. Photosynthesis in plants generally involves the green pigment chlorophyll and generates oxygen as a byproduct.</a:t>
-            </a:r>
-            <a:br/>
-            <a:br/>
-            <a:r>
-              <a:t>Simply put: Plants use solar energy, water, and air to make their own food and release clean air for us to breathe!”</a:t>
+              <a:t>• data_prep.py: Ingests, formats, and tokenizes subset.</a:t>
+            </a:r>
+          </a:p>
+          <a:p>
+            <a:pPr>
+              <a:spcBef>
+                <a:spcPts val="500"/>
+              </a:spcBef>
+              <a:defRPr sz="1100">
+                <a:solidFill>
+                  <a:srgbClr val="475569"/>
+                </a:solidFill>
+                <a:latin typeface="Calibri"/>
+              </a:defRPr>
+            </a:pPr>
+            <a:r>
+              <a:t>• train.py: Loads TinyLlama, applies LoRA, executes training loop.</a:t>
+            </a:r>
+          </a:p>
+          <a:p>
+            <a:pPr>
+              <a:spcBef>
+                <a:spcPts val="500"/>
+              </a:spcBef>
+              <a:defRPr sz="1100">
+                <a:solidFill>
+                  <a:srgbClr val="475569"/>
+                </a:solidFill>
+                <a:latin typeface="Calibri"/>
+              </a:defRPr>
+            </a:pPr>
+            <a:r>
+              <a:t>• inference.py: Interactive command-line testing script.</a:t>
+            </a:r>
+          </a:p>
+          <a:p>
+            <a:pPr>
+              <a:spcBef>
+                <a:spcPts val="500"/>
+              </a:spcBef>
+              <a:defRPr sz="1100">
+                <a:solidFill>
+                  <a:srgbClr val="475569"/>
+                </a:solidFill>
+                <a:latin typeface="Calibri"/>
+              </a:defRPr>
+            </a:pPr>
+            <a:r>
+              <a:t>• app.py: Streamlit local deployment GUI with fallbacks.</a:t>
+            </a:r>
+          </a:p>
+          <a:p>
+            <a:pPr>
+              <a:spcBef>
+                <a:spcPts val="500"/>
+              </a:spcBef>
+              <a:defRPr sz="1100">
+                <a:solidFill>
+                  <a:srgbClr val="475569"/>
+                </a:solidFill>
+                <a:latin typeface="Calibri"/>
+              </a:defRPr>
+            </a:pPr>
+            <a:r>
+              <a:t>• architecture.md: Comprehensive technical system overview.</a:t>
+            </a:r>
+          </a:p>
+          <a:p>
+            <a:pPr>
+              <a:spcBef>
+                <a:spcPts val="500"/>
+              </a:spcBef>
+              <a:defRPr sz="1100">
+                <a:solidFill>
+                  <a:srgbClr val="475569"/>
+                </a:solidFill>
+                <a:latin typeface="Calibri"/>
+              </a:defRPr>
+            </a:pPr>
+            <a:r>
+              <a:t>• generate_ppt.py: Programmatic layout specifications for presentation.</a:t>
             </a:r>
           </a:p>
         </p:txBody>

</xml_diff>